<commit_message>
Reestructurar el curso en 7 clases y una Clase Extra
- Clase 1 junta la presentación y la nivelación de la vieja 1b. La app de la
  tabla pasa al estilo del curso y se suma primeros_pasos.R.
- Clase 7 junta estética y navegación con la app final y su publicación.
  Queda solo la app final, con datos/ y deploy.R.
- revisor_corpus pasa a ser la Clase Extra (clase_extra.pptx).
- Se borran clase1b, clase8 y los PDF viejos.
- README, datos/README.md y preparar_elecciones_2024.R con la nueva numeración.
</commit_message>
<xml_diff>
--- a/clase7/clase7.pptx
+++ b/clase7/clase7.pptx
@@ -14,9 +14,15 @@
     <p:sldId id="258" r:id="rId5"/>
     <p:sldId id="264" r:id="rId6"/>
     <p:sldId id="265" r:id="rId7"/>
+    <p:sldId id="266" r:id="rId18"/>
+    <p:sldId id="267" r:id="rId19"/>
+    <p:sldId id="268" r:id="rId20"/>
+    <p:sldId id="269" r:id="rId21"/>
     <p:sldId id="259" r:id="rId8"/>
+    <p:sldId id="270" r:id="rId22"/>
     <p:sldId id="260" r:id="rId9"/>
-    <p:sldId id="262" r:id="rId10"/>
+    <p:sldId id="271" r:id="rId23"/>
+    <p:sldId id="272" r:id="rId24"/>
   </p:sldIdLst>
   <p:sldSz cx="9144000" cy="5143500" type="screen16x9"/>
   <p:notesSz cx="5143500" cy="9144000"/>
@@ -1570,90 +1576,6 @@
 </p:notes>
 </file>
 
-<file path=ppt/notesSlides/notesSlide9.xml><?xml version="1.0" encoding="utf-8"?>
-<p:notes xmlns:a="http://schemas.openxmlformats.org/drawingml/2006/main" xmlns:r="http://schemas.openxmlformats.org/officeDocument/2006/relationships" xmlns:p="http://schemas.openxmlformats.org/presentationml/2006/main">
-  <p:cSld>
-    <p:spTree>
-      <p:nvGrpSpPr>
-        <p:cNvPr id="1" name=""/>
-        <p:cNvGrpSpPr/>
-        <p:nvPr/>
-      </p:nvGrpSpPr>
-      <p:grpSpPr>
-        <a:xfrm>
-          <a:off x="0" y="0"/>
-          <a:ext cx="0" cy="0"/>
-          <a:chOff x="0" y="0"/>
-          <a:chExt cx="0" cy="0"/>
-        </a:xfrm>
-      </p:grpSpPr>
-      <p:sp>
-        <p:nvSpPr>
-          <p:cNvPr id="2" name="Slide Image Placeholder 1"/>
-          <p:cNvSpPr>
-            <a:spLocks noGrp="1" noRot="1" noChangeAspect="1"/>
-          </p:cNvSpPr>
-          <p:nvPr>
-            <p:ph type="sldImg"/>
-          </p:nvPr>
-        </p:nvSpPr>
-        <p:spPr/>
-      </p:sp>
-      <p:sp>
-        <p:nvSpPr>
-          <p:cNvPr id="3" name="Notes Placeholder 2"/>
-          <p:cNvSpPr>
-            <a:spLocks noGrp="1"/>
-          </p:cNvSpPr>
-          <p:nvPr>
-            <p:ph type="body" idx="1"/>
-          </p:nvPr>
-        </p:nvSpPr>
-        <p:spPr/>
-        <p:txBody>
-          <a:bodyPr/>
-          <a:lstStyle/>
-          <a:p>
-            <a:endParaRPr lang="en-US" dirty="0"/>
-          </a:p>
-        </p:txBody>
-      </p:sp>
-      <p:sp>
-        <p:nvSpPr>
-          <p:cNvPr id="4" name="Slide Number Placeholder 3"/>
-          <p:cNvSpPr>
-            <a:spLocks noGrp="1"/>
-          </p:cNvSpPr>
-          <p:nvPr>
-            <p:ph type="sldNum" sz="quarter" idx="10"/>
-          </p:nvPr>
-        </p:nvSpPr>
-        <p:spPr/>
-        <p:txBody>
-          <a:bodyPr/>
-          <a:lstStyle/>
-          <a:p>
-            <a:fld id="{F7021451-1387-4CA6-816F-3879F97B5CBC}" type="slidenum">
-              <a:rPr lang="en-US"/>
-              <a:t>9</a:t>
-            </a:fld>
-            <a:endParaRPr lang="en-US"/>
-          </a:p>
-        </p:txBody>
-      </p:sp>
-    </p:spTree>
-    <p:extLst>
-      <p:ext uri="{BB962C8B-B14F-4D97-AF65-F5344CB8AC3E}">
-        <p14:creationId xmlns:p14="http://schemas.microsoft.com/office/powerpoint/2010/main" val="1024086991"/>
-      </p:ext>
-    </p:extLst>
-  </p:cSld>
-  <p:clrMapOvr>
-    <a:masterClrMapping/>
-  </p:clrMapOvr>
-</p:notes>
-</file>
-
 <file path=ppt/slideLayouts/slideLayout1.xml><?xml version="1.0" encoding="utf-8"?>
 <p:sldLayout xmlns:a="http://schemas.openxmlformats.org/drawingml/2006/main" xmlns:r="http://schemas.openxmlformats.org/officeDocument/2006/relationships" xmlns:p="http://schemas.openxmlformats.org/presentationml/2006/main" preserve="1">
   <p:cSld name="DEFAULT">
@@ -2050,7 +1972,7 @@
               <a:buNone/>
             </a:pPr>
             <a:r>
-              <a:rPr lang="en-US" sz="3400" b="1" dirty="0">
+              <a:rPr lang="en-US" sz="2800" b="1" dirty="0">
                 <a:solidFill>
                   <a:srgbClr val="2E0A4E"/>
                 </a:solidFill>
@@ -2058,7 +1980,7 @@
                 <a:ea typeface="Oswald" pitchFamily="34" charset="-122"/>
                 <a:cs typeface="Oswald" pitchFamily="34" charset="-120"/>
               </a:rPr>
-              <a:t>Estética y navegación</a:t>
+              <a:t>Estética, la app final y su publicación</a:t>
             </a:r>
             <a:endParaRPr lang="en-US" sz="3400" dirty="0"/>
           </a:p>
@@ -2097,7 +2019,7 @@
                 <a:ea typeface="Calibri" pitchFamily="34" charset="-122"/>
                 <a:cs typeface="Calibri" pitchFamily="34" charset="-120"/>
               </a:rPr>
-              <a:t>Temas, barra de navegación, cajas y tablas interactivas</a:t>
+              <a:t>Temas, navegación, tablas, mapas y publicación en la web</a:t>
             </a:r>
             <a:endParaRPr lang="en-US" sz="1800" dirty="0"/>
           </a:p>
@@ -2139,6 +2061,3147 @@
               <a:t>Visualización interactiva de datos con R y Shiny · Udelar</a:t>
             </a:r>
             <a:endParaRPr lang="en-US" sz="1200" dirty="0"/>
+          </a:p>
+        </p:txBody>
+      </p:sp>
+    </p:spTree>
+  </p:cSld>
+  <p:clrMapOvr>
+    <a:masterClrMapping/>
+  </p:clrMapOvr>
+</p:sld>
+</file>
+
+<file path=ppt/slides/slide10.xml><?xml version="1.0" encoding="utf-8"?>
+<p:sld xmlns:a="http://schemas.openxmlformats.org/drawingml/2006/main" xmlns:p="http://schemas.openxmlformats.org/presentationml/2006/main" xmlns:r="http://schemas.openxmlformats.org/officeDocument/2006/relationships">
+  <p:cSld>
+    <p:bg>
+      <p:bgPr>
+        <a:solidFill>
+          <a:srgbClr val="FFFFFF"/>
+        </a:solidFill>
+        <a:effectLst/>
+      </p:bgPr>
+    </p:bg>
+    <p:spTree>
+      <p:nvGrpSpPr>
+        <p:cNvPr id="1" name=""/>
+        <p:cNvGrpSpPr/>
+        <p:nvPr/>
+      </p:nvGrpSpPr>
+      <p:grpSpPr/>
+      <p:sp>
+        <p:nvSpPr>
+          <p:cNvPr id="2" name="Text 0">
+            <a:extLst>
+              <a:ext uri="{FF2B5EF4-FFF2-40B4-BE49-F238E27FC236}">
+                <a16:creationId xmlns:a16="http://schemas.microsoft.com/office/drawing/2014/main" id="{45FBCF84-BF0C-00DD-1115-ECF03D12DDA6}"/>
+              </a:ext>
+            </a:extLst>
+          </p:cNvPr>
+          <p:cNvSpPr txBox="1"/>
+          <p:nvPr/>
+        </p:nvSpPr>
+        <p:spPr>
+          <a:xfrm>
+            <a:off x="502920" y="320040"/>
+            <a:ext cx="7040880" cy="640080"/>
+          </a:xfrm>
+          <a:prstGeom prst="rect">
+            <a:avLst/>
+          </a:prstGeom>
+          <a:noFill/>
+          <a:ln/>
+        </p:spPr>
+        <p:txBody>
+          <a:bodyPr wrap="square" lIns="0" tIns="0" rIns="0" bIns="0" rtlCol="0" anchor="ctr"/>
+          <a:lstStyle/>
+          <a:p>
+            <a:pPr marL="0" indent="0">
+              <a:buNone/>
+            </a:pPr>
+            <a:r>
+              <a:rPr lang="en-US" sz="3000" b="1" dirty="0">
+                <a:solidFill>
+                  <a:srgbClr val="2E0A4E"/>
+                </a:solidFill>
+                <a:latin typeface="Oswald" pitchFamily="34" charset="0"/>
+                <a:ea typeface="Oswald" pitchFamily="34" charset="-122"/>
+                <a:cs typeface="Oswald" pitchFamily="34" charset="-120"/>
+              </a:rPr>
+              <a:t>La app de hoy (5)</a:t>
+            </a:r>
+            <a:endParaRPr lang="en-US" sz="3000" dirty="0"/>
+          </a:p>
+        </p:txBody>
+      </p:sp>
+      <p:sp>
+        <p:nvSpPr>
+          <p:cNvPr id="11" name="Shape 9">
+            <a:extLst>
+              <a:ext uri="{FF2B5EF4-FFF2-40B4-BE49-F238E27FC236}">
+                <a16:creationId xmlns:a16="http://schemas.microsoft.com/office/drawing/2014/main" id="{1E4D2BBF-BB0F-7CF4-3842-6325D6A2CD35}"/>
+              </a:ext>
+            </a:extLst>
+          </p:cNvPr>
+          <p:cNvSpPr/>
+          <p:nvPr/>
+        </p:nvSpPr>
+        <p:spPr>
+          <a:xfrm>
+            <a:off x="439616" y="1188720"/>
+            <a:ext cx="2560320" cy="1463040"/>
+          </a:xfrm>
+          <a:prstGeom prst="roundRect">
+            <a:avLst>
+              <a:gd name="adj" fmla="val 2143"/>
+            </a:avLst>
+          </a:prstGeom>
+          <a:solidFill>
+            <a:srgbClr val="5A189A"/>
+          </a:solidFill>
+          <a:ln w="12700">
+            <a:solidFill>
+              <a:srgbClr val="5A189A"/>
+            </a:solidFill>
+            <a:prstDash val="solid"/>
+          </a:ln>
+        </p:spPr>
+        <p:txBody>
+          <a:bodyPr/>
+          <a:lstStyle/>
+          <a:p>
+            <a:endParaRPr lang="en-US"/>
+          </a:p>
+        </p:txBody>
+      </p:sp>
+      <p:sp>
+        <p:nvSpPr>
+          <p:cNvPr id="12" name="Text 10">
+            <a:extLst>
+              <a:ext uri="{FF2B5EF4-FFF2-40B4-BE49-F238E27FC236}">
+                <a16:creationId xmlns:a16="http://schemas.microsoft.com/office/drawing/2014/main" id="{57EA7703-08D4-E6C4-4FDB-5B08F7881055}"/>
+              </a:ext>
+            </a:extLst>
+          </p:cNvPr>
+          <p:cNvSpPr txBox="1"/>
+          <p:nvPr/>
+        </p:nvSpPr>
+        <p:spPr>
+          <a:xfrm>
+            <a:off x="668216" y="1256068"/>
+            <a:ext cx="2103120" cy="502920"/>
+          </a:xfrm>
+          <a:prstGeom prst="rect">
+            <a:avLst/>
+          </a:prstGeom>
+          <a:noFill/>
+          <a:ln/>
+        </p:spPr>
+        <p:txBody>
+          <a:bodyPr wrap="square" lIns="0" tIns="0" rIns="0" bIns="0" rtlCol="0" anchor="ctr"/>
+          <a:lstStyle/>
+          <a:p>
+            <a:pPr marL="0" indent="0">
+              <a:buNone/>
+            </a:pPr>
+            <a:r>
+              <a:rPr lang="en-US" sz="1600" b="1" dirty="0">
+                <a:solidFill>
+                  <a:srgbClr val="FFFFFF"/>
+                </a:solidFill>
+                <a:latin typeface="Oswald" pitchFamily="34" charset="0"/>
+                <a:ea typeface="Oswald" pitchFamily="34" charset="-122"/>
+                <a:cs typeface="Oswald" pitchFamily="34" charset="-120"/>
+              </a:rPr>
+              <a:t>OBJETIVO 4</a:t>
+            </a:r>
+            <a:endParaRPr lang="en-US" sz="1600" dirty="0"/>
+          </a:p>
+        </p:txBody>
+      </p:sp>
+      <p:sp>
+        <p:nvSpPr>
+          <p:cNvPr id="13" name="Text 11">
+            <a:extLst>
+              <a:ext uri="{FF2B5EF4-FFF2-40B4-BE49-F238E27FC236}">
+                <a16:creationId xmlns:a16="http://schemas.microsoft.com/office/drawing/2014/main" id="{83082800-1689-F508-4C9C-8E0187A18BDD}"/>
+              </a:ext>
+            </a:extLst>
+          </p:cNvPr>
+          <p:cNvSpPr txBox="1"/>
+          <p:nvPr/>
+        </p:nvSpPr>
+        <p:spPr>
+          <a:xfrm>
+            <a:off x="668216" y="1734572"/>
+            <a:ext cx="2103120" cy="716926"/>
+          </a:xfrm>
+          <a:prstGeom prst="rect">
+            <a:avLst/>
+          </a:prstGeom>
+          <a:noFill/>
+          <a:ln/>
+        </p:spPr>
+        <p:txBody>
+          <a:bodyPr wrap="square" lIns="0" tIns="0" rIns="0" bIns="0" rtlCol="0" anchor="t"/>
+          <a:lstStyle/>
+          <a:p>
+            <a:r>
+              <a:rPr lang="es-ES" sz="1400" dirty="0">
+                <a:solidFill>
+                  <a:schemeClr val="bg1"/>
+                </a:solidFill>
+                <a:latin typeface="Calibri" pitchFamily="34" charset="0"/>
+                <a:ea typeface="Calibri" pitchFamily="34" charset="-122"/>
+                <a:cs typeface="Calibri" pitchFamily="34" charset="-120"/>
+              </a:rPr>
+              <a:t>Tres paneles, doce visualizaciones</a:t>
+            </a:r>
+            <a:endParaRPr lang="en-US" sz="1300" dirty="0"/>
+          </a:p>
+        </p:txBody>
+      </p:sp>
+      <p:sp>
+        <p:nvSpPr>
+          <p:cNvPr id="15" name="Shape 9">
+            <a:extLst>
+              <a:ext uri="{FF2B5EF4-FFF2-40B4-BE49-F238E27FC236}">
+                <a16:creationId xmlns:a16="http://schemas.microsoft.com/office/drawing/2014/main" id="{E750D06A-626A-4348-CA99-CE04C627A232}"/>
+              </a:ext>
+            </a:extLst>
+          </p:cNvPr>
+          <p:cNvSpPr/>
+          <p:nvPr/>
+        </p:nvSpPr>
+        <p:spPr>
+          <a:xfrm>
+            <a:off x="439615" y="2719107"/>
+            <a:ext cx="3773659" cy="2281957"/>
+          </a:xfrm>
+          <a:prstGeom prst="roundRect">
+            <a:avLst>
+              <a:gd name="adj" fmla="val 2143"/>
+            </a:avLst>
+          </a:prstGeom>
+          <a:solidFill>
+            <a:schemeClr val="accent1">
+              <a:lumMod val="75000"/>
+            </a:schemeClr>
+          </a:solidFill>
+          <a:ln w="12700">
+            <a:solidFill>
+              <a:schemeClr val="accent1">
+                <a:lumMod val="75000"/>
+              </a:schemeClr>
+            </a:solidFill>
+            <a:prstDash val="solid"/>
+          </a:ln>
+        </p:spPr>
+        <p:txBody>
+          <a:bodyPr/>
+          <a:lstStyle/>
+          <a:p>
+            <a:endParaRPr lang="en-US"/>
+          </a:p>
+        </p:txBody>
+      </p:sp>
+      <p:sp>
+        <p:nvSpPr>
+          <p:cNvPr id="17" name="Text 11">
+            <a:extLst>
+              <a:ext uri="{FF2B5EF4-FFF2-40B4-BE49-F238E27FC236}">
+                <a16:creationId xmlns:a16="http://schemas.microsoft.com/office/drawing/2014/main" id="{F3440954-5CFF-06C7-8641-E2E38BA6F847}"/>
+              </a:ext>
+            </a:extLst>
+          </p:cNvPr>
+          <p:cNvSpPr txBox="1"/>
+          <p:nvPr/>
+        </p:nvSpPr>
+        <p:spPr>
+          <a:xfrm>
+            <a:off x="668216" y="2899117"/>
+            <a:ext cx="3369212" cy="716926"/>
+          </a:xfrm>
+          <a:prstGeom prst="rect">
+            <a:avLst/>
+          </a:prstGeom>
+          <a:noFill/>
+          <a:ln/>
+        </p:spPr>
+        <p:txBody>
+          <a:bodyPr wrap="square" lIns="0" tIns="0" rIns="0" bIns="0" rtlCol="0" anchor="t"/>
+          <a:lstStyle/>
+          <a:p>
+            <a:r>
+              <a:rPr lang="es-ES" sz="1400" b="1" dirty="0">
+                <a:solidFill>
+                  <a:schemeClr val="bg1"/>
+                </a:solidFill>
+                <a:latin typeface="Calibri" pitchFamily="34" charset="0"/>
+                <a:ea typeface="Calibri" pitchFamily="34" charset="-122"/>
+                <a:cs typeface="Calibri" pitchFamily="34" charset="-120"/>
+              </a:rPr>
+              <a:t>Gráficos, Tablas y Mapas son tres </a:t>
+            </a:r>
+            <a:r>
+              <a:rPr lang="es-ES" sz="1400" b="1" dirty="0" i="1">
+                <a:solidFill>
+                  <a:schemeClr val="bg1"/>
+                </a:solidFill>
+                <a:latin typeface="Calibri" pitchFamily="34" charset="0"/>
+                <a:ea typeface="Calibri" pitchFamily="34" charset="-122"/>
+                <a:cs typeface="Calibri" pitchFamily="34" charset="-120"/>
+              </a:rPr>
+              <a:t>nav_panel()</a:t>
+            </a:r>
+            <a:r>
+              <a:rPr lang="es-ES" sz="1400" b="1" dirty="0">
+                <a:solidFill>
+                  <a:schemeClr val="bg1"/>
+                </a:solidFill>
+                <a:latin typeface="Calibri" pitchFamily="34" charset="0"/>
+                <a:ea typeface="Calibri" pitchFamily="34" charset="-122"/>
+                <a:cs typeface="Calibri" pitchFamily="34" charset="-120"/>
+              </a:rPr>
+              <a:t> nuevos. En cada uno, </a:t>
+            </a:r>
+            <a:r>
+              <a:rPr lang="es-ES" sz="1400" b="1" dirty="0" i="1">
+                <a:solidFill>
+                  <a:schemeClr val="bg1"/>
+                </a:solidFill>
+                <a:latin typeface="Calibri" pitchFamily="34" charset="0"/>
+                <a:ea typeface="Calibri" pitchFamily="34" charset="-122"/>
+                <a:cs typeface="Calibri" pitchFamily="34" charset="-120"/>
+              </a:rPr>
+              <a:t>layout_columns(col_widths = 6)</a:t>
+            </a:r>
+            <a:r>
+              <a:rPr lang="es-ES" sz="1400" b="1" dirty="0">
+                <a:solidFill>
+                  <a:schemeClr val="bg1"/>
+                </a:solidFill>
+                <a:latin typeface="Calibri" pitchFamily="34" charset="0"/>
+                <a:ea typeface="Calibri" pitchFamily="34" charset="-122"/>
+                <a:cs typeface="Calibri" pitchFamily="34" charset="-120"/>
+              </a:rPr>
+              <a:t> acomoda cuatro </a:t>
+            </a:r>
+            <a:r>
+              <a:rPr lang="es-ES" sz="1400" b="1" dirty="0" i="1">
+                <a:solidFill>
+                  <a:schemeClr val="bg1"/>
+                </a:solidFill>
+                <a:latin typeface="Calibri" pitchFamily="34" charset="0"/>
+                <a:ea typeface="Calibri" pitchFamily="34" charset="-122"/>
+                <a:cs typeface="Calibri" pitchFamily="34" charset="-120"/>
+              </a:rPr>
+              <a:t>card()</a:t>
+            </a:r>
+            <a:r>
+              <a:rPr lang="es-ES" sz="1400" b="1" dirty="0">
+                <a:solidFill>
+                  <a:schemeClr val="bg1"/>
+                </a:solidFill>
+                <a:latin typeface="Calibri" pitchFamily="34" charset="0"/>
+                <a:ea typeface="Calibri" pitchFamily="34" charset="-122"/>
+                <a:cs typeface="Calibri" pitchFamily="34" charset="-120"/>
+              </a:rPr>
+              <a:t> de a dos por fila.</a:t>
+            </a:r>
+          </a:p>
+          <a:p/>
+          <a:p>
+            <a:r>
+              <a:rPr lang="es-ES" sz="1400" b="1" dirty="0">
+                <a:solidFill>
+                  <a:schemeClr val="bg1"/>
+                </a:solidFill>
+                <a:latin typeface="Calibri" pitchFamily="34" charset="0"/>
+                <a:ea typeface="Calibri" pitchFamily="34" charset="-122"/>
+                <a:cs typeface="Calibri" pitchFamily="34" charset="-120"/>
+              </a:rPr>
+              <a:t>Todo lo demás es lo que ya vimos, ggplot2, plotly y DT.</a:t>
+            </a:r>
+          </a:p>
+        </p:txBody>
+      </p:sp>
+      <p:pic>
+        <p:nvPicPr>
+          <p:cNvPr id="22" name="Picture 21" descr="q1.png"/>
+          <p:cNvPicPr>
+            <a:picLocks noChangeAspect="1"/>
+          </p:cNvPicPr>
+          <p:nvPr/>
+        </p:nvPicPr>
+        <p:blipFill>
+          <a:blip r:embed="rId7"/>
+          <a:stretch>
+            <a:fillRect/>
+          </a:stretch>
+        </p:blipFill>
+        <p:spPr>
+          <a:xfrm>
+            <a:off x="4434840" y="1280160"/>
+            <a:ext cx="4480560" cy="2880360"/>
+          </a:xfrm>
+          <a:prstGeom prst="rect">
+            <a:avLst/>
+          </a:prstGeom>
+          <a:ln w="76200">
+            <a:solidFill>
+              <a:schemeClr val="accent1">
+                <a:lumMod val="75000"/>
+              </a:schemeClr>
+            </a:solidFill>
+          </a:ln>
+        </p:spPr>
+      </p:pic>
+    </p:spTree>
+  </p:cSld>
+  <p:clrMapOvr>
+    <a:masterClrMapping/>
+  </p:clrMapOvr>
+</p:sld>
+</file>
+
+<file path=ppt/slides/slide11.xml><?xml version="1.0" encoding="utf-8"?>
+<p:sld xmlns:a="http://schemas.openxmlformats.org/drawingml/2006/main" xmlns:p="http://schemas.openxmlformats.org/presentationml/2006/main" xmlns:r="http://schemas.openxmlformats.org/officeDocument/2006/relationships">
+  <p:cSld>
+    <p:bg>
+      <p:bgPr>
+        <a:solidFill>
+          <a:srgbClr val="FFFFFF"/>
+        </a:solidFill>
+        <a:effectLst/>
+      </p:bgPr>
+    </p:bg>
+    <p:spTree>
+      <p:nvGrpSpPr>
+        <p:cNvPr id="1" name=""/>
+        <p:cNvGrpSpPr/>
+        <p:nvPr/>
+      </p:nvGrpSpPr>
+      <p:grpSpPr/>
+      <p:sp>
+        <p:nvSpPr>
+          <p:cNvPr id="2" name="Text 0"/>
+          <p:cNvSpPr txBox="1"/>
+          <p:nvPr/>
+        </p:nvSpPr>
+        <p:spPr>
+          <a:xfrm>
+            <a:off x="502920" y="320040"/>
+            <a:ext cx="7040880" cy="640080"/>
+          </a:xfrm>
+          <a:prstGeom prst="rect">
+            <a:avLst/>
+          </a:prstGeom>
+          <a:noFill/>
+          <a:ln/>
+        </p:spPr>
+        <p:txBody>
+          <a:bodyPr wrap="square" lIns="0" tIns="0" rIns="0" bIns="0" rtlCol="0" anchor="ctr"/>
+          <a:lstStyle/>
+          <a:p>
+            <a:r>
+              <a:rPr lang="en-US" sz="3000" b="1" dirty="0">
+                <a:solidFill>
+                  <a:srgbClr val="2E0A4E"/>
+                </a:solidFill>
+                <a:latin typeface="Oswald" pitchFamily="34" charset="0"/>
+                <a:ea typeface="Oswald" pitchFamily="34" charset="-122"/>
+                <a:cs typeface="Oswald" pitchFamily="34" charset="-120"/>
+              </a:rPr>
+              <a:t>La app de hoy (6)</a:t>
+            </a:r>
+            <a:endParaRPr lang="en-US" sz="3000" dirty="0"/>
+          </a:p>
+        </p:txBody>
+      </p:sp>
+      <p:sp>
+        <p:nvSpPr>
+          <p:cNvPr id="11" name="Shape 9"/>
+          <p:cNvSpPr/>
+          <p:nvPr/>
+        </p:nvSpPr>
+        <p:spPr>
+          <a:xfrm>
+            <a:off x="439616" y="1188720"/>
+            <a:ext cx="2560320" cy="1463040"/>
+          </a:xfrm>
+          <a:prstGeom prst="roundRect">
+            <a:avLst>
+              <a:gd name="adj" fmla="val 2143"/>
+            </a:avLst>
+          </a:prstGeom>
+          <a:solidFill>
+            <a:srgbClr val="5A189A"/>
+          </a:solidFill>
+          <a:ln w="12700">
+            <a:solidFill>
+              <a:srgbClr val="5A189A"/>
+            </a:solidFill>
+            <a:prstDash val="solid"/>
+          </a:ln>
+        </p:spPr>
+        <p:txBody>
+          <a:bodyPr/>
+          <a:lstStyle/>
+          <a:p>
+            <a:endParaRPr lang="en-US"/>
+          </a:p>
+        </p:txBody>
+      </p:sp>
+      <p:sp>
+        <p:nvSpPr>
+          <p:cNvPr id="12" name="Text 10"/>
+          <p:cNvSpPr txBox="1"/>
+          <p:nvPr/>
+        </p:nvSpPr>
+        <p:spPr>
+          <a:xfrm>
+            <a:off x="668216" y="1256068"/>
+            <a:ext cx="2103120" cy="502920"/>
+          </a:xfrm>
+          <a:prstGeom prst="rect">
+            <a:avLst/>
+          </a:prstGeom>
+          <a:noFill/>
+          <a:ln/>
+        </p:spPr>
+        <p:txBody>
+          <a:bodyPr wrap="square" lIns="0" tIns="0" rIns="0" bIns="0" rtlCol="0" anchor="ctr"/>
+          <a:lstStyle/>
+          <a:p>
+            <a:pPr marL="0" indent="0">
+              <a:buNone/>
+            </a:pPr>
+            <a:r>
+              <a:rPr lang="en-US" sz="1600" b="1" dirty="0">
+                <a:solidFill>
+                  <a:srgbClr val="FFFFFF"/>
+                </a:solidFill>
+                <a:latin typeface="Oswald" pitchFamily="34" charset="0"/>
+                <a:ea typeface="Oswald" pitchFamily="34" charset="-122"/>
+                <a:cs typeface="Oswald" pitchFamily="34" charset="-120"/>
+              </a:rPr>
+              <a:t>OBJETIVO 4</a:t>
+            </a:r>
+            <a:endParaRPr lang="en-US" sz="1600" dirty="0"/>
+          </a:p>
+        </p:txBody>
+      </p:sp>
+      <p:sp>
+        <p:nvSpPr>
+          <p:cNvPr id="13" name="Text 11"/>
+          <p:cNvSpPr txBox="1"/>
+          <p:nvPr/>
+        </p:nvSpPr>
+        <p:spPr>
+          <a:xfrm>
+            <a:off x="668216" y="1734572"/>
+            <a:ext cx="2103120" cy="716926"/>
+          </a:xfrm>
+          <a:prstGeom prst="rect">
+            <a:avLst/>
+          </a:prstGeom>
+          <a:noFill/>
+          <a:ln/>
+        </p:spPr>
+        <p:txBody>
+          <a:bodyPr wrap="square" lIns="0" tIns="0" rIns="0" bIns="0" rtlCol="0" anchor="t"/>
+          <a:lstStyle/>
+          <a:p>
+            <a:r>
+              <a:rPr lang="es-ES" sz="1400" dirty="0">
+                <a:solidFill>
+                  <a:schemeClr val="bg1"/>
+                </a:solidFill>
+                <a:latin typeface="Calibri" pitchFamily="34" charset="0"/>
+                <a:ea typeface="Calibri" pitchFamily="34" charset="-122"/>
+                <a:cs typeface="Calibri" pitchFamily="34" charset="-120"/>
+              </a:rPr>
+              <a:t>Mapas con leaflet</a:t>
+            </a:r>
+            <a:endParaRPr lang="en-US" sz="1300" dirty="0"/>
+          </a:p>
+        </p:txBody>
+      </p:sp>
+      <p:sp>
+        <p:nvSpPr>
+          <p:cNvPr id="15" name="Shape 9">
+            <a:extLst>
+              <a:ext uri="{FF2B5EF4-FFF2-40B4-BE49-F238E27FC236}">
+                <a16:creationId xmlns:a16="http://schemas.microsoft.com/office/drawing/2014/main" id="{1ED05ED1-CE50-06A2-178F-B4365671B18F}"/>
+              </a:ext>
+            </a:extLst>
+          </p:cNvPr>
+          <p:cNvSpPr/>
+          <p:nvPr/>
+        </p:nvSpPr>
+        <p:spPr>
+          <a:xfrm>
+            <a:off x="439615" y="2719107"/>
+            <a:ext cx="3773659" cy="2281957"/>
+          </a:xfrm>
+          <a:prstGeom prst="roundRect">
+            <a:avLst>
+              <a:gd name="adj" fmla="val 2143"/>
+            </a:avLst>
+          </a:prstGeom>
+          <a:solidFill>
+            <a:schemeClr val="accent1">
+              <a:lumMod val="75000"/>
+            </a:schemeClr>
+          </a:solidFill>
+          <a:ln w="12700">
+            <a:solidFill>
+              <a:schemeClr val="accent1">
+                <a:lumMod val="75000"/>
+              </a:schemeClr>
+            </a:solidFill>
+            <a:prstDash val="solid"/>
+          </a:ln>
+        </p:spPr>
+        <p:txBody>
+          <a:bodyPr/>
+          <a:lstStyle/>
+          <a:p>
+            <a:endParaRPr lang="en-US"/>
+          </a:p>
+        </p:txBody>
+      </p:sp>
+      <p:sp>
+        <p:nvSpPr>
+          <p:cNvPr id="17" name="Text 11">
+            <a:extLst>
+              <a:ext uri="{FF2B5EF4-FFF2-40B4-BE49-F238E27FC236}">
+                <a16:creationId xmlns:a16="http://schemas.microsoft.com/office/drawing/2014/main" id="{1291722D-C809-2238-9939-339690D52438}"/>
+              </a:ext>
+            </a:extLst>
+          </p:cNvPr>
+          <p:cNvSpPr txBox="1"/>
+          <p:nvPr/>
+        </p:nvSpPr>
+        <p:spPr>
+          <a:xfrm>
+            <a:off x="668216" y="2899117"/>
+            <a:ext cx="3369212" cy="716926"/>
+          </a:xfrm>
+          <a:prstGeom prst="rect">
+            <a:avLst/>
+          </a:prstGeom>
+          <a:noFill/>
+          <a:ln/>
+        </p:spPr>
+        <p:txBody>
+          <a:bodyPr wrap="square" lIns="0" tIns="0" rIns="0" bIns="0" rtlCol="0" anchor="t"/>
+          <a:lstStyle/>
+          <a:p>
+            <a:r>
+              <a:rPr lang="es-ES" sz="1400" b="1" dirty="0" err="1" i="1">
+                <a:solidFill>
+                  <a:schemeClr val="bg1"/>
+                </a:solidFill>
+                <a:latin typeface="Calibri" pitchFamily="34" charset="0"/>
+                <a:ea typeface="Calibri" pitchFamily="34" charset="-122"/>
+                <a:cs typeface="Calibri" pitchFamily="34" charset="-120"/>
+              </a:rPr>
+              <a:t>leaflet(l) |&gt; addProviderTiles() |&gt; addCircleMarkers() |&gt; addLegend()</a:t>
+            </a:r>
+            <a:r>
+              <a:rPr lang="es-ES" sz="1400" b="1" dirty="0" err="1">
+                <a:solidFill>
+                  <a:schemeClr val="bg1"/>
+                </a:solidFill>
+                <a:latin typeface="Calibri" pitchFamily="34" charset="0"/>
+                <a:ea typeface="Calibri" pitchFamily="34" charset="-122"/>
+                <a:cs typeface="Calibri" pitchFamily="34" charset="-120"/>
+              </a:rPr>
+              <a:t> arma el mapa por partes, como un ggplot.</a:t>
+            </a:r>
+          </a:p>
+          <a:p/>
+          <a:p>
+            <a:r>
+              <a:rPr lang="es-ES" sz="1400" b="1" dirty="0" err="1" i="1">
+                <a:solidFill>
+                  <a:schemeClr val="bg1"/>
+                </a:solidFill>
+                <a:latin typeface="Calibri" pitchFamily="34" charset="0"/>
+                <a:ea typeface="Calibri" pitchFamily="34" charset="-122"/>
+                <a:cs typeface="Calibri" pitchFamily="34" charset="-120"/>
+              </a:rPr>
+              <a:t>colorFactor()</a:t>
+            </a:r>
+            <a:r>
+              <a:rPr lang="es-ES" sz="1400" b="1" dirty="0" err="1">
+                <a:solidFill>
+                  <a:schemeClr val="bg1"/>
+                </a:solidFill>
+                <a:latin typeface="Calibri" pitchFamily="34" charset="0"/>
+                <a:ea typeface="Calibri" pitchFamily="34" charset="-122"/>
+                <a:cs typeface="Calibri" pitchFamily="34" charset="-120"/>
+              </a:rPr>
+              <a:t> colorea por categoría y </a:t>
+            </a:r>
+            <a:r>
+              <a:rPr lang="es-ES" sz="1400" b="1" dirty="0" err="1" i="1">
+                <a:solidFill>
+                  <a:schemeClr val="bg1"/>
+                </a:solidFill>
+                <a:latin typeface="Calibri" pitchFamily="34" charset="0"/>
+                <a:ea typeface="Calibri" pitchFamily="34" charset="-122"/>
+                <a:cs typeface="Calibri" pitchFamily="34" charset="-120"/>
+              </a:rPr>
+              <a:t>colorNumeric()</a:t>
+            </a:r>
+            <a:r>
+              <a:rPr lang="es-ES" sz="1400" b="1" dirty="0" err="1">
+                <a:solidFill>
+                  <a:schemeClr val="bg1"/>
+                </a:solidFill>
+                <a:latin typeface="Calibri" pitchFamily="34" charset="0"/>
+                <a:ea typeface="Calibri" pitchFamily="34" charset="-122"/>
+                <a:cs typeface="Calibri" pitchFamily="34" charset="-120"/>
+              </a:rPr>
+              <a:t> por porcentaje. Cada punto es un local de votación.</a:t>
+            </a:r>
+          </a:p>
+        </p:txBody>
+      </p:sp>
+      <p:pic>
+        <p:nvPicPr>
+          <p:cNvPr id="24" name="Picture 23" descr="q2.png"/>
+          <p:cNvPicPr>
+            <a:picLocks noChangeAspect="1"/>
+          </p:cNvPicPr>
+          <p:nvPr/>
+        </p:nvPicPr>
+        <p:blipFill>
+          <a:blip r:embed="rId7"/>
+          <a:stretch>
+            <a:fillRect/>
+          </a:stretch>
+        </p:blipFill>
+        <p:spPr>
+          <a:xfrm>
+            <a:off x="4434840" y="1065812"/>
+            <a:ext cx="4480560" cy="3309055"/>
+          </a:xfrm>
+          <a:prstGeom prst="rect">
+            <a:avLst/>
+          </a:prstGeom>
+          <a:ln w="76200">
+            <a:solidFill>
+              <a:schemeClr val="accent1">
+                <a:lumMod val="75000"/>
+              </a:schemeClr>
+            </a:solidFill>
+          </a:ln>
+        </p:spPr>
+      </p:pic>
+    </p:spTree>
+  </p:cSld>
+  <p:clrMapOvr>
+    <a:masterClrMapping/>
+  </p:clrMapOvr>
+</p:sld>
+</file>
+
+<file path=ppt/slides/slide12.xml><?xml version="1.0" encoding="utf-8"?>
+<p:sld xmlns:a="http://schemas.openxmlformats.org/drawingml/2006/main" xmlns:p="http://schemas.openxmlformats.org/presentationml/2006/main" xmlns:r="http://schemas.openxmlformats.org/officeDocument/2006/relationships">
+  <p:cSld>
+    <p:bg>
+      <p:bgPr>
+        <a:solidFill>
+          <a:srgbClr val="FFFFFF"/>
+        </a:solidFill>
+        <a:effectLst/>
+      </p:bgPr>
+    </p:bg>
+    <p:spTree>
+      <p:nvGrpSpPr>
+        <p:cNvPr id="1" name=""/>
+        <p:cNvGrpSpPr/>
+        <p:nvPr/>
+      </p:nvGrpSpPr>
+      <p:grpSpPr/>
+      <p:sp>
+        <p:nvSpPr>
+          <p:cNvPr id="2" name="Text 0">
+            <a:extLst>
+              <a:ext uri="{FF2B5EF4-FFF2-40B4-BE49-F238E27FC236}">
+                <a16:creationId xmlns:a16="http://schemas.microsoft.com/office/drawing/2014/main" id="{1B8BE186-2227-0AEE-46BF-1738518AF7E2}"/>
+              </a:ext>
+            </a:extLst>
+          </p:cNvPr>
+          <p:cNvSpPr txBox="1"/>
+          <p:nvPr/>
+        </p:nvSpPr>
+        <p:spPr>
+          <a:xfrm>
+            <a:off x="502920" y="320040"/>
+            <a:ext cx="7040880" cy="640080"/>
+          </a:xfrm>
+          <a:prstGeom prst="rect">
+            <a:avLst/>
+          </a:prstGeom>
+          <a:noFill/>
+          <a:ln/>
+        </p:spPr>
+        <p:txBody>
+          <a:bodyPr wrap="square" lIns="0" tIns="0" rIns="0" bIns="0" rtlCol="0" anchor="ctr"/>
+          <a:lstStyle/>
+          <a:p>
+            <a:r>
+              <a:rPr lang="en-US" sz="3000" b="1" dirty="0">
+                <a:solidFill>
+                  <a:srgbClr val="2E0A4E"/>
+                </a:solidFill>
+                <a:latin typeface="Oswald" pitchFamily="34" charset="0"/>
+                <a:ea typeface="Oswald" pitchFamily="34" charset="-122"/>
+                <a:cs typeface="Oswald" pitchFamily="34" charset="-120"/>
+              </a:rPr>
+              <a:t>La app de hoy (7)</a:t>
+            </a:r>
+            <a:endParaRPr lang="en-US" sz="3000" dirty="0"/>
+          </a:p>
+        </p:txBody>
+      </p:sp>
+      <p:sp>
+        <p:nvSpPr>
+          <p:cNvPr id="11" name="Shape 9">
+            <a:extLst>
+              <a:ext uri="{FF2B5EF4-FFF2-40B4-BE49-F238E27FC236}">
+                <a16:creationId xmlns:a16="http://schemas.microsoft.com/office/drawing/2014/main" id="{2D484EA3-17D5-DFDE-7FFB-391D9E546766}"/>
+              </a:ext>
+            </a:extLst>
+          </p:cNvPr>
+          <p:cNvSpPr/>
+          <p:nvPr/>
+        </p:nvSpPr>
+        <p:spPr>
+          <a:xfrm>
+            <a:off x="439616" y="1188720"/>
+            <a:ext cx="2560320" cy="1463040"/>
+          </a:xfrm>
+          <a:prstGeom prst="roundRect">
+            <a:avLst>
+              <a:gd name="adj" fmla="val 2143"/>
+            </a:avLst>
+          </a:prstGeom>
+          <a:solidFill>
+            <a:srgbClr val="5A189A"/>
+          </a:solidFill>
+          <a:ln w="12700">
+            <a:solidFill>
+              <a:srgbClr val="5A189A"/>
+            </a:solidFill>
+            <a:prstDash val="solid"/>
+          </a:ln>
+        </p:spPr>
+        <p:txBody>
+          <a:bodyPr/>
+          <a:lstStyle/>
+          <a:p>
+            <a:endParaRPr lang="en-US"/>
+          </a:p>
+        </p:txBody>
+      </p:sp>
+      <p:sp>
+        <p:nvSpPr>
+          <p:cNvPr id="12" name="Text 10">
+            <a:extLst>
+              <a:ext uri="{FF2B5EF4-FFF2-40B4-BE49-F238E27FC236}">
+                <a16:creationId xmlns:a16="http://schemas.microsoft.com/office/drawing/2014/main" id="{FF346D48-99B4-78ED-CF54-DB6A3D402E26}"/>
+              </a:ext>
+            </a:extLst>
+          </p:cNvPr>
+          <p:cNvSpPr txBox="1"/>
+          <p:nvPr/>
+        </p:nvSpPr>
+        <p:spPr>
+          <a:xfrm>
+            <a:off x="668216" y="1256068"/>
+            <a:ext cx="2103120" cy="502920"/>
+          </a:xfrm>
+          <a:prstGeom prst="rect">
+            <a:avLst/>
+          </a:prstGeom>
+          <a:noFill/>
+          <a:ln/>
+        </p:spPr>
+        <p:txBody>
+          <a:bodyPr wrap="square" lIns="0" tIns="0" rIns="0" bIns="0" rtlCol="0" anchor="ctr"/>
+          <a:lstStyle/>
+          <a:p>
+            <a:pPr marL="0" indent="0">
+              <a:buNone/>
+            </a:pPr>
+            <a:r>
+              <a:rPr lang="en-US" sz="1600" b="1" dirty="0">
+                <a:solidFill>
+                  <a:srgbClr val="FFFFFF"/>
+                </a:solidFill>
+                <a:latin typeface="Oswald" pitchFamily="34" charset="0"/>
+                <a:ea typeface="Oswald" pitchFamily="34" charset="-122"/>
+                <a:cs typeface="Oswald" pitchFamily="34" charset="-120"/>
+              </a:rPr>
+              <a:t>OBJETIVO 5</a:t>
+            </a:r>
+            <a:endParaRPr lang="en-US" sz="1600" dirty="0"/>
+          </a:p>
+        </p:txBody>
+      </p:sp>
+      <p:sp>
+        <p:nvSpPr>
+          <p:cNvPr id="13" name="Text 11">
+            <a:extLst>
+              <a:ext uri="{FF2B5EF4-FFF2-40B4-BE49-F238E27FC236}">
+                <a16:creationId xmlns:a16="http://schemas.microsoft.com/office/drawing/2014/main" id="{961D826F-99A4-C802-E6F8-FA059D329199}"/>
+              </a:ext>
+            </a:extLst>
+          </p:cNvPr>
+          <p:cNvSpPr txBox="1"/>
+          <p:nvPr/>
+        </p:nvSpPr>
+        <p:spPr>
+          <a:xfrm>
+            <a:off x="668216" y="1734572"/>
+            <a:ext cx="2103120" cy="716926"/>
+          </a:xfrm>
+          <a:prstGeom prst="rect">
+            <a:avLst/>
+          </a:prstGeom>
+          <a:noFill/>
+          <a:ln/>
+        </p:spPr>
+        <p:txBody>
+          <a:bodyPr wrap="square" lIns="0" tIns="0" rIns="0" bIns="0" rtlCol="0" anchor="t"/>
+          <a:lstStyle/>
+          <a:p>
+            <a:r>
+              <a:rPr lang="es-ES" sz="1400" dirty="0">
+                <a:solidFill>
+                  <a:schemeClr val="bg1"/>
+                </a:solidFill>
+                <a:latin typeface="Calibri" pitchFamily="34" charset="0"/>
+                <a:ea typeface="Calibri" pitchFamily="34" charset="-122"/>
+                <a:cs typeface="Calibri" pitchFamily="34" charset="-120"/>
+              </a:rPr>
+              <a:t>Los mismos filtros para todo</a:t>
+            </a:r>
+          </a:p>
+        </p:txBody>
+      </p:sp>
+      <p:sp>
+        <p:nvSpPr>
+          <p:cNvPr id="15" name="Shape 9">
+            <a:extLst>
+              <a:ext uri="{FF2B5EF4-FFF2-40B4-BE49-F238E27FC236}">
+                <a16:creationId xmlns:a16="http://schemas.microsoft.com/office/drawing/2014/main" id="{F33AC7BE-75B4-F8D4-43E0-87B7AD3B3F34}"/>
+              </a:ext>
+            </a:extLst>
+          </p:cNvPr>
+          <p:cNvSpPr/>
+          <p:nvPr/>
+        </p:nvSpPr>
+        <p:spPr>
+          <a:xfrm>
+            <a:off x="439615" y="2719107"/>
+            <a:ext cx="3773659" cy="2281957"/>
+          </a:xfrm>
+          <a:prstGeom prst="roundRect">
+            <a:avLst>
+              <a:gd name="adj" fmla="val 2143"/>
+            </a:avLst>
+          </a:prstGeom>
+          <a:solidFill>
+            <a:schemeClr val="accent1">
+              <a:lumMod val="75000"/>
+            </a:schemeClr>
+          </a:solidFill>
+          <a:ln w="12700">
+            <a:solidFill>
+              <a:schemeClr val="accent1">
+                <a:lumMod val="75000"/>
+              </a:schemeClr>
+            </a:solidFill>
+            <a:prstDash val="solid"/>
+          </a:ln>
+        </p:spPr>
+        <p:txBody>
+          <a:bodyPr/>
+          <a:lstStyle/>
+          <a:p>
+            <a:endParaRPr lang="en-US"/>
+          </a:p>
+        </p:txBody>
+      </p:sp>
+      <p:sp>
+        <p:nvSpPr>
+          <p:cNvPr id="17" name="Text 11">
+            <a:extLst>
+              <a:ext uri="{FF2B5EF4-FFF2-40B4-BE49-F238E27FC236}">
+                <a16:creationId xmlns:a16="http://schemas.microsoft.com/office/drawing/2014/main" id="{BFEECB63-4CC8-9CA3-665B-7BF2CFCADD52}"/>
+              </a:ext>
+            </a:extLst>
+          </p:cNvPr>
+          <p:cNvSpPr txBox="1"/>
+          <p:nvPr/>
+        </p:nvSpPr>
+        <p:spPr>
+          <a:xfrm>
+            <a:off x="668216" y="2899117"/>
+            <a:ext cx="3369212" cy="716926"/>
+          </a:xfrm>
+          <a:prstGeom prst="rect">
+            <a:avLst/>
+          </a:prstGeom>
+          <a:noFill/>
+          <a:ln/>
+        </p:spPr>
+        <p:txBody>
+          <a:bodyPr wrap="square" lIns="0" tIns="0" rIns="0" bIns="0" rtlCol="0" anchor="t"/>
+          <a:lstStyle/>
+          <a:p>
+            <a:r>
+              <a:rPr lang="es-ES" sz="1400" b="1" dirty="0" i="1">
+                <a:solidFill>
+                  <a:schemeClr val="bg1"/>
+                </a:solidFill>
+                <a:latin typeface="Calibri" pitchFamily="34" charset="0"/>
+                <a:ea typeface="Calibri" pitchFamily="34" charset="-122"/>
+                <a:cs typeface="Calibri" pitchFamily="34" charset="-120"/>
+              </a:rPr>
+              <a:t>locales_filtrados()</a:t>
+            </a:r>
+            <a:r>
+              <a:rPr lang="es-ES" sz="1400" b="1" dirty="0">
+                <a:solidFill>
+                  <a:schemeClr val="bg1"/>
+                </a:solidFill>
+                <a:latin typeface="Calibri" pitchFamily="34" charset="0"/>
+                <a:ea typeface="Calibri" pitchFamily="34" charset="-122"/>
+                <a:cs typeface="Calibri" pitchFamily="34" charset="-120"/>
+              </a:rPr>
+              <a:t> y </a:t>
+            </a:r>
+            <a:r>
+              <a:rPr lang="es-ES" sz="1400" b="1" dirty="0" i="1">
+                <a:solidFill>
+                  <a:schemeClr val="bg1"/>
+                </a:solidFill>
+                <a:latin typeface="Calibri" pitchFamily="34" charset="0"/>
+                <a:ea typeface="Calibri" pitchFamily="34" charset="-122"/>
+                <a:cs typeface="Calibri" pitchFamily="34" charset="-120"/>
+              </a:rPr>
+              <a:t>censo_filtrado()</a:t>
+            </a:r>
+            <a:r>
+              <a:rPr lang="es-ES" sz="1400" b="1" dirty="0">
+                <a:solidFill>
+                  <a:schemeClr val="bg1"/>
+                </a:solidFill>
+                <a:latin typeface="Calibri" pitchFamily="34" charset="0"/>
+                <a:ea typeface="Calibri" pitchFamily="34" charset="-122"/>
+                <a:cs typeface="Calibri" pitchFamily="34" charset="-120"/>
+              </a:rPr>
+              <a:t> se quedan con los departamentos que hay en </a:t>
+            </a:r>
+            <a:r>
+              <a:rPr lang="es-ES" sz="1400" b="1" dirty="0" i="1">
+                <a:solidFill>
+                  <a:schemeClr val="bg1"/>
+                </a:solidFill>
+                <a:latin typeface="Calibri" pitchFamily="34" charset="0"/>
+                <a:ea typeface="Calibri" pitchFamily="34" charset="-122"/>
+                <a:cs typeface="Calibri" pitchFamily="34" charset="-120"/>
+              </a:rPr>
+              <a:t>datos()</a:t>
+            </a:r>
+            <a:r>
+              <a:rPr lang="es-ES" sz="1400" b="1" dirty="0">
+                <a:solidFill>
+                  <a:schemeClr val="bg1"/>
+                </a:solidFill>
+                <a:latin typeface="Calibri" pitchFamily="34" charset="0"/>
+                <a:ea typeface="Calibri" pitchFamily="34" charset="-122"/>
+                <a:cs typeface="Calibri" pitchFamily="34" charset="-120"/>
+              </a:rPr>
+              <a:t>.</a:t>
+            </a:r>
+            <a:endParaRPr lang="en-US" sz="1300" dirty="0"/>
+          </a:p>
+          <a:p>
+            <a:endParaRPr lang="en-US" sz="1300" dirty="0"/>
+          </a:p>
+          <a:p>
+            <a:r>
+              <a:rPr lang="es-ES" sz="1400" b="1" dirty="0">
+                <a:solidFill>
+                  <a:schemeClr val="bg1"/>
+                </a:solidFill>
+                <a:latin typeface="Calibri" pitchFamily="34" charset="0"/>
+                <a:ea typeface="Calibri" pitchFamily="34" charset="-122"/>
+                <a:cs typeface="Calibri" pitchFamily="34" charset="-120"/>
+              </a:rPr>
+              <a:t>Eligiendo solo la región Norte, los cuatro mapas y las tablas muestran solo el Norte.</a:t>
+            </a:r>
+            <a:endParaRPr lang="en-US" sz="1300" dirty="0"/>
+          </a:p>
+        </p:txBody>
+      </p:sp>
+      <p:pic>
+        <p:nvPicPr>
+          <p:cNvPr id="22" name="Picture 21" descr="q3.png"/>
+          <p:cNvPicPr>
+            <a:picLocks noChangeAspect="1"/>
+          </p:cNvPicPr>
+          <p:nvPr/>
+        </p:nvPicPr>
+        <p:blipFill>
+          <a:blip r:embed="rId7"/>
+          <a:stretch>
+            <a:fillRect/>
+          </a:stretch>
+        </p:blipFill>
+        <p:spPr>
+          <a:xfrm>
+            <a:off x="4434840" y="1280160"/>
+            <a:ext cx="4480560" cy="2880360"/>
+          </a:xfrm>
+          <a:prstGeom prst="rect">
+            <a:avLst/>
+          </a:prstGeom>
+          <a:ln w="76200">
+            <a:solidFill>
+              <a:schemeClr val="accent1">
+                <a:lumMod val="75000"/>
+              </a:schemeClr>
+            </a:solidFill>
+          </a:ln>
+        </p:spPr>
+      </p:pic>
+    </p:spTree>
+  </p:cSld>
+  <p:clrMapOvr>
+    <a:masterClrMapping/>
+  </p:clrMapOvr>
+</p:sld>
+</file>
+
+<file path=ppt/slides/slide13.xml><?xml version="1.0" encoding="utf-8"?>
+<p:sld xmlns:a="http://schemas.openxmlformats.org/drawingml/2006/main" xmlns:p="http://schemas.openxmlformats.org/presentationml/2006/main" xmlns:r="http://schemas.openxmlformats.org/officeDocument/2006/relationships">
+  <p:cSld>
+    <p:bg>
+      <p:bgPr>
+        <a:solidFill>
+          <a:srgbClr val="FFFFFF"/>
+        </a:solidFill>
+        <a:effectLst/>
+      </p:bgPr>
+    </p:bg>
+    <p:spTree>
+      <p:nvGrpSpPr>
+        <p:cNvPr id="1" name=""/>
+        <p:cNvGrpSpPr/>
+        <p:nvPr/>
+      </p:nvGrpSpPr>
+      <p:grpSpPr/>
+      <p:sp>
+        <p:nvSpPr>
+          <p:cNvPr id="2" name="Text 0">
+            <a:extLst>
+              <a:ext uri="{FF2B5EF4-FFF2-40B4-BE49-F238E27FC236}">
+                <a16:creationId xmlns:a16="http://schemas.microsoft.com/office/drawing/2014/main" id="{21E0B84E-B772-A594-B980-A7B918F749C6}"/>
+              </a:ext>
+            </a:extLst>
+          </p:cNvPr>
+          <p:cNvSpPr txBox="1"/>
+          <p:nvPr/>
+        </p:nvSpPr>
+        <p:spPr>
+          <a:xfrm>
+            <a:off x="502920" y="320040"/>
+            <a:ext cx="7040880" cy="640080"/>
+          </a:xfrm>
+          <a:prstGeom prst="rect">
+            <a:avLst/>
+          </a:prstGeom>
+          <a:noFill/>
+          <a:ln/>
+        </p:spPr>
+        <p:txBody>
+          <a:bodyPr wrap="square" lIns="0" tIns="0" rIns="0" bIns="0" rtlCol="0" anchor="ctr"/>
+          <a:lstStyle/>
+          <a:p>
+            <a:r>
+              <a:rPr lang="en-US" sz="3000" b="1" dirty="0">
+                <a:solidFill>
+                  <a:srgbClr val="2E0A4E"/>
+                </a:solidFill>
+                <a:latin typeface="Oswald" pitchFamily="34" charset="0"/>
+                <a:ea typeface="Oswald" pitchFamily="34" charset="-122"/>
+                <a:cs typeface="Oswald" pitchFamily="34" charset="-120"/>
+              </a:rPr>
+              <a:t>La app de hoy (8)</a:t>
+            </a:r>
+            <a:endParaRPr lang="en-US" sz="3000" dirty="0"/>
+          </a:p>
+        </p:txBody>
+      </p:sp>
+      <p:sp>
+        <p:nvSpPr>
+          <p:cNvPr id="11" name="Shape 9">
+            <a:extLst>
+              <a:ext uri="{FF2B5EF4-FFF2-40B4-BE49-F238E27FC236}">
+                <a16:creationId xmlns:a16="http://schemas.microsoft.com/office/drawing/2014/main" id="{8584C834-90F2-8AA8-B328-3643E4CCE677}"/>
+              </a:ext>
+            </a:extLst>
+          </p:cNvPr>
+          <p:cNvSpPr/>
+          <p:nvPr/>
+        </p:nvSpPr>
+        <p:spPr>
+          <a:xfrm>
+            <a:off x="439616" y="1188720"/>
+            <a:ext cx="2560320" cy="1463040"/>
+          </a:xfrm>
+          <a:prstGeom prst="roundRect">
+            <a:avLst>
+              <a:gd name="adj" fmla="val 2143"/>
+            </a:avLst>
+          </a:prstGeom>
+          <a:solidFill>
+            <a:srgbClr val="5A189A"/>
+          </a:solidFill>
+          <a:ln w="12700">
+            <a:solidFill>
+              <a:srgbClr val="5A189A"/>
+            </a:solidFill>
+            <a:prstDash val="solid"/>
+          </a:ln>
+        </p:spPr>
+        <p:txBody>
+          <a:bodyPr/>
+          <a:lstStyle/>
+          <a:p>
+            <a:endParaRPr lang="en-US"/>
+          </a:p>
+        </p:txBody>
+      </p:sp>
+      <p:sp>
+        <p:nvSpPr>
+          <p:cNvPr id="12" name="Text 10">
+            <a:extLst>
+              <a:ext uri="{FF2B5EF4-FFF2-40B4-BE49-F238E27FC236}">
+                <a16:creationId xmlns:a16="http://schemas.microsoft.com/office/drawing/2014/main" id="{3D0787E2-7C7C-7A9C-ED72-1B8D5BA244E4}"/>
+              </a:ext>
+            </a:extLst>
+          </p:cNvPr>
+          <p:cNvSpPr txBox="1"/>
+          <p:nvPr/>
+        </p:nvSpPr>
+        <p:spPr>
+          <a:xfrm>
+            <a:off x="668216" y="1256068"/>
+            <a:ext cx="2103120" cy="502920"/>
+          </a:xfrm>
+          <a:prstGeom prst="rect">
+            <a:avLst/>
+          </a:prstGeom>
+          <a:noFill/>
+          <a:ln/>
+        </p:spPr>
+        <p:txBody>
+          <a:bodyPr wrap="square" lIns="0" tIns="0" rIns="0" bIns="0" rtlCol="0" anchor="ctr"/>
+          <a:lstStyle/>
+          <a:p>
+            <a:pPr marL="0" indent="0">
+              <a:buNone/>
+            </a:pPr>
+            <a:r>
+              <a:rPr lang="en-US" sz="1600" b="1" dirty="0">
+                <a:solidFill>
+                  <a:srgbClr val="FFFFFF"/>
+                </a:solidFill>
+                <a:latin typeface="Oswald" pitchFamily="34" charset="0"/>
+                <a:ea typeface="Oswald" pitchFamily="34" charset="-122"/>
+                <a:cs typeface="Oswald" pitchFamily="34" charset="-120"/>
+              </a:rPr>
+              <a:t>OBJETIVO 6</a:t>
+            </a:r>
+            <a:endParaRPr lang="en-US" sz="1600" dirty="0"/>
+          </a:p>
+        </p:txBody>
+      </p:sp>
+      <p:sp>
+        <p:nvSpPr>
+          <p:cNvPr id="13" name="Text 11">
+            <a:extLst>
+              <a:ext uri="{FF2B5EF4-FFF2-40B4-BE49-F238E27FC236}">
+                <a16:creationId xmlns:a16="http://schemas.microsoft.com/office/drawing/2014/main" id="{0C2592C3-39BA-DB09-D0F1-BF73ED6DEC99}"/>
+              </a:ext>
+            </a:extLst>
+          </p:cNvPr>
+          <p:cNvSpPr txBox="1"/>
+          <p:nvPr/>
+        </p:nvSpPr>
+        <p:spPr>
+          <a:xfrm>
+            <a:off x="668216" y="1734572"/>
+            <a:ext cx="2103120" cy="716926"/>
+          </a:xfrm>
+          <a:prstGeom prst="rect">
+            <a:avLst/>
+          </a:prstGeom>
+          <a:noFill/>
+          <a:ln/>
+        </p:spPr>
+        <p:txBody>
+          <a:bodyPr wrap="square" lIns="0" tIns="0" rIns="0" bIns="0" rtlCol="0" anchor="t"/>
+          <a:lstStyle/>
+          <a:p>
+            <a:r>
+              <a:rPr lang="es-ES" sz="1400" dirty="0">
+                <a:solidFill>
+                  <a:schemeClr val="bg1"/>
+                </a:solidFill>
+                <a:latin typeface="Calibri" pitchFamily="34" charset="0"/>
+                <a:ea typeface="Calibri" pitchFamily="34" charset="-122"/>
+                <a:cs typeface="Calibri" pitchFamily="34" charset="-120"/>
+              </a:rPr>
+              <a:t>Publicar la app</a:t>
+            </a:r>
+          </a:p>
+        </p:txBody>
+      </p:sp>
+      <p:sp>
+        <p:nvSpPr>
+          <p:cNvPr id="15" name="Shape 9">
+            <a:extLst>
+              <a:ext uri="{FF2B5EF4-FFF2-40B4-BE49-F238E27FC236}">
+                <a16:creationId xmlns:a16="http://schemas.microsoft.com/office/drawing/2014/main" id="{ADB729CB-A987-663A-1058-A842556E3C9E}"/>
+              </a:ext>
+            </a:extLst>
+          </p:cNvPr>
+          <p:cNvSpPr/>
+          <p:nvPr/>
+        </p:nvSpPr>
+        <p:spPr>
+          <a:xfrm>
+            <a:off x="439615" y="2719107"/>
+            <a:ext cx="3773659" cy="2281957"/>
+          </a:xfrm>
+          <a:prstGeom prst="roundRect">
+            <a:avLst>
+              <a:gd name="adj" fmla="val 2143"/>
+            </a:avLst>
+          </a:prstGeom>
+          <a:solidFill>
+            <a:schemeClr val="accent1">
+              <a:lumMod val="75000"/>
+            </a:schemeClr>
+          </a:solidFill>
+          <a:ln w="12700">
+            <a:solidFill>
+              <a:schemeClr val="accent1">
+                <a:lumMod val="75000"/>
+              </a:schemeClr>
+            </a:solidFill>
+            <a:prstDash val="solid"/>
+          </a:ln>
+        </p:spPr>
+        <p:txBody>
+          <a:bodyPr/>
+          <a:lstStyle/>
+          <a:p>
+            <a:endParaRPr lang="en-US"/>
+          </a:p>
+        </p:txBody>
+      </p:sp>
+      <p:sp>
+        <p:nvSpPr>
+          <p:cNvPr id="17" name="Text 11">
+            <a:extLst>
+              <a:ext uri="{FF2B5EF4-FFF2-40B4-BE49-F238E27FC236}">
+                <a16:creationId xmlns:a16="http://schemas.microsoft.com/office/drawing/2014/main" id="{90C1F140-6606-DACA-D829-EF5414EB787C}"/>
+              </a:ext>
+            </a:extLst>
+          </p:cNvPr>
+          <p:cNvSpPr txBox="1"/>
+          <p:nvPr/>
+        </p:nvSpPr>
+        <p:spPr>
+          <a:xfrm>
+            <a:off x="647115" y="2880360"/>
+            <a:ext cx="3369212" cy="716926"/>
+          </a:xfrm>
+          <a:prstGeom prst="rect">
+            <a:avLst/>
+          </a:prstGeom>
+          <a:noFill/>
+          <a:ln/>
+        </p:spPr>
+        <p:txBody>
+          <a:bodyPr wrap="square" lIns="0" tIns="0" rIns="0" bIns="0" rtlCol="0" anchor="t"/>
+          <a:lstStyle/>
+          <a:p>
+            <a:r>
+              <a:rPr lang="es-ES" sz="1400" b="1" dirty="0">
+                <a:solidFill>
+                  <a:schemeClr val="bg1"/>
+                </a:solidFill>
+                <a:latin typeface="Calibri" pitchFamily="34" charset="0"/>
+                <a:ea typeface="Calibri" pitchFamily="34" charset="-122"/>
+                <a:cs typeface="Calibri" pitchFamily="34" charset="-120"/>
+              </a:rPr>
+              <a:t>Los datos viajan con la app, en la carpeta </a:t>
+            </a:r>
+            <a:r>
+              <a:rPr lang="es-ES" sz="1400" b="1" dirty="0" i="1">
+                <a:solidFill>
+                  <a:schemeClr val="bg1"/>
+                </a:solidFill>
+                <a:latin typeface="Calibri" pitchFamily="34" charset="0"/>
+                <a:ea typeface="Calibri" pitchFamily="34" charset="-122"/>
+                <a:cs typeface="Calibri" pitchFamily="34" charset="-120"/>
+              </a:rPr>
+              <a:t>datos/</a:t>
+            </a:r>
+            <a:r>
+              <a:rPr lang="es-ES" sz="1400" b="1" dirty="0">
+                <a:solidFill>
+                  <a:schemeClr val="bg1"/>
+                </a:solidFill>
+                <a:latin typeface="Calibri" pitchFamily="34" charset="0"/>
+                <a:ea typeface="Calibri" pitchFamily="34" charset="-122"/>
+                <a:cs typeface="Calibri" pitchFamily="34" charset="-120"/>
+              </a:rPr>
+              <a:t> de la clase. Por eso la ruta ya no empieza con </a:t>
+            </a:r>
+            <a:r>
+              <a:rPr lang="es-ES" sz="1400" b="1" dirty="0" i="1">
+                <a:solidFill>
+                  <a:schemeClr val="bg1"/>
+                </a:solidFill>
+                <a:latin typeface="Calibri" pitchFamily="34" charset="0"/>
+                <a:ea typeface="Calibri" pitchFamily="34" charset="-122"/>
+                <a:cs typeface="Calibri" pitchFamily="34" charset="-120"/>
+              </a:rPr>
+              <a:t>../</a:t>
+            </a:r>
+            <a:r>
+              <a:rPr lang="es-ES" sz="1400" b="1" dirty="0">
+                <a:solidFill>
+                  <a:schemeClr val="bg1"/>
+                </a:solidFill>
+                <a:latin typeface="Calibri" pitchFamily="34" charset="0"/>
+                <a:ea typeface="Calibri" pitchFamily="34" charset="-122"/>
+                <a:cs typeface="Calibri" pitchFamily="34" charset="-120"/>
+              </a:rPr>
+              <a:t>.</a:t>
+            </a:r>
+            <a:endParaRPr lang="en-US" sz="1300" dirty="0"/>
+          </a:p>
+          <a:p>
+            <a:endParaRPr lang="en-US" sz="1300" dirty="0"/>
+          </a:p>
+          <a:p>
+            <a:r>
+              <a:rPr lang="es-ES" sz="1400" b="1" dirty="0" i="1">
+                <a:solidFill>
+                  <a:schemeClr val="bg1"/>
+                </a:solidFill>
+                <a:latin typeface="Calibri" pitchFamily="34" charset="0"/>
+                <a:ea typeface="Calibri" pitchFamily="34" charset="-122"/>
+                <a:cs typeface="Calibri" pitchFamily="34" charset="-120"/>
+              </a:rPr>
+              <a:t>deploy.R</a:t>
+            </a:r>
+            <a:r>
+              <a:rPr lang="es-ES" sz="1400" b="1" dirty="0">
+                <a:solidFill>
+                  <a:schemeClr val="bg1"/>
+                </a:solidFill>
+                <a:latin typeface="Calibri" pitchFamily="34" charset="0"/>
+                <a:ea typeface="Calibri" pitchFamily="34" charset="-122"/>
+                <a:cs typeface="Calibri" pitchFamily="34" charset="-120"/>
+              </a:rPr>
+              <a:t> tiene los pasos. </a:t>
+            </a:r>
+            <a:r>
+              <a:rPr lang="es-ES" sz="1400" b="1" dirty="0" i="1">
+                <a:solidFill>
+                  <a:schemeClr val="bg1"/>
+                </a:solidFill>
+                <a:latin typeface="Calibri" pitchFamily="34" charset="0"/>
+                <a:ea typeface="Calibri" pitchFamily="34" charset="-122"/>
+                <a:cs typeface="Calibri" pitchFamily="34" charset="-120"/>
+              </a:rPr>
+              <a:t>rsconnect::deployApp()</a:t>
+            </a:r>
+            <a:r>
+              <a:rPr lang="es-ES" sz="1400" b="1" dirty="0">
+                <a:solidFill>
+                  <a:schemeClr val="bg1"/>
+                </a:solidFill>
+                <a:latin typeface="Calibri" pitchFamily="34" charset="0"/>
+                <a:ea typeface="Calibri" pitchFamily="34" charset="-122"/>
+                <a:cs typeface="Calibri" pitchFamily="34" charset="-120"/>
+              </a:rPr>
+              <a:t> publica y </a:t>
+            </a:r>
+            <a:r>
+              <a:rPr lang="es-ES" sz="1400" b="1" dirty="0" i="1">
+                <a:solidFill>
+                  <a:schemeClr val="bg1"/>
+                </a:solidFill>
+                <a:latin typeface="Calibri" pitchFamily="34" charset="0"/>
+                <a:ea typeface="Calibri" pitchFamily="34" charset="-122"/>
+                <a:cs typeface="Calibri" pitchFamily="34" charset="-120"/>
+              </a:rPr>
+              <a:t>showLogs()</a:t>
+            </a:r>
+            <a:r>
+              <a:rPr lang="es-ES" sz="1400" b="1" dirty="0">
+                <a:solidFill>
+                  <a:schemeClr val="bg1"/>
+                </a:solidFill>
+                <a:latin typeface="Calibri" pitchFamily="34" charset="0"/>
+                <a:ea typeface="Calibri" pitchFamily="34" charset="-122"/>
+                <a:cs typeface="Calibri" pitchFamily="34" charset="-120"/>
+              </a:rPr>
+              <a:t> muestra qué falló.</a:t>
+            </a:r>
+            <a:endParaRPr lang="en-US" sz="1300" dirty="0"/>
+          </a:p>
+        </p:txBody>
+      </p:sp>
+      <p:pic>
+        <p:nvPicPr>
+          <p:cNvPr id="22" name="Picture 21" descr="q4.png"/>
+          <p:cNvPicPr>
+            <a:picLocks noChangeAspect="1"/>
+          </p:cNvPicPr>
+          <p:nvPr/>
+        </p:nvPicPr>
+        <p:blipFill>
+          <a:blip r:embed="rId8"/>
+          <a:stretch>
+            <a:fillRect/>
+          </a:stretch>
+        </p:blipFill>
+        <p:spPr>
+          <a:xfrm>
+            <a:off x="4434840" y="1576303"/>
+            <a:ext cx="4480560" cy="2288072"/>
+          </a:xfrm>
+          <a:prstGeom prst="rect">
+            <a:avLst/>
+          </a:prstGeom>
+          <a:ln w="76200">
+            <a:solidFill>
+              <a:schemeClr val="accent1">
+                <a:lumMod val="75000"/>
+              </a:schemeClr>
+            </a:solidFill>
+          </a:ln>
+        </p:spPr>
+      </p:pic>
+    </p:spTree>
+  </p:cSld>
+  <p:clrMapOvr>
+    <a:masterClrMapping/>
+  </p:clrMapOvr>
+</p:sld>
+</file>
+
+<file path=ppt/slides/slide14.xml><?xml version="1.0" encoding="utf-8"?>
+<p:sld xmlns:a="http://schemas.openxmlformats.org/drawingml/2006/main" xmlns:p="http://schemas.openxmlformats.org/presentationml/2006/main" xmlns:r="http://schemas.openxmlformats.org/officeDocument/2006/relationships">
+  <p:cSld>
+    <p:bg>
+      <p:bgPr>
+        <a:solidFill>
+          <a:srgbClr val="FFFFFF"/>
+        </a:solidFill>
+        <a:effectLst/>
+      </p:bgPr>
+    </p:bg>
+    <p:spTree>
+      <p:nvGrpSpPr>
+        <p:cNvPr id="1" name=""/>
+        <p:cNvGrpSpPr/>
+        <p:nvPr/>
+      </p:nvGrpSpPr>
+      <p:grpSpPr/>
+      <p:sp>
+        <p:nvSpPr>
+          <p:cNvPr id="2" name="Text 0"/>
+          <p:cNvSpPr txBox="1"/>
+          <p:nvPr/>
+        </p:nvSpPr>
+        <p:spPr>
+          <a:xfrm>
+            <a:off x="502920" y="320040"/>
+            <a:ext cx="7040880" cy="640080"/>
+          </a:xfrm>
+          <a:prstGeom prst="rect">
+            <a:avLst/>
+          </a:prstGeom>
+          <a:noFill/>
+          <a:ln/>
+        </p:spPr>
+        <p:txBody>
+          <a:bodyPr wrap="square" lIns="0" tIns="0" rIns="0" bIns="0" rtlCol="0" anchor="ctr"/>
+          <a:lstStyle/>
+          <a:p>
+            <a:pPr marL="0" indent="0">
+              <a:buNone/>
+            </a:pPr>
+            <a:r>
+              <a:rPr lang="en-US" sz="3000" b="1" dirty="0">
+                <a:solidFill>
+                  <a:srgbClr val="2E0A4E"/>
+                </a:solidFill>
+                <a:latin typeface="Oswald" pitchFamily="34" charset="0"/>
+                <a:ea typeface="Oswald" pitchFamily="34" charset="-122"/>
+                <a:cs typeface="Oswald" pitchFamily="34" charset="-120"/>
+              </a:rPr>
+              <a:t>Componentes a </a:t>
+            </a:r>
+            <a:r>
+              <a:rPr lang="en-US" sz="3000" b="1" dirty="0" err="1">
+                <a:solidFill>
+                  <a:srgbClr val="2E0A4E"/>
+                </a:solidFill>
+                <a:latin typeface="Oswald" pitchFamily="34" charset="0"/>
+                <a:ea typeface="Oswald" pitchFamily="34" charset="-122"/>
+                <a:cs typeface="Oswald" pitchFamily="34" charset="-120"/>
+              </a:rPr>
+              <a:t>observar</a:t>
+            </a:r>
+            <a:r>
+              <a:rPr lang="en-US" sz="3000" b="1" dirty="0">
+                <a:solidFill>
+                  <a:srgbClr val="2E0A4E"/>
+                </a:solidFill>
+                <a:latin typeface="Oswald" pitchFamily="34" charset="0"/>
+                <a:ea typeface="Oswald" pitchFamily="34" charset="-122"/>
+                <a:cs typeface="Oswald" pitchFamily="34" charset="-120"/>
+              </a:rPr>
+              <a:t> en la </a:t>
+            </a:r>
+            <a:r>
+              <a:rPr lang="en-US" sz="3000" b="1" dirty="0" err="1">
+                <a:solidFill>
+                  <a:srgbClr val="2E0A4E"/>
+                </a:solidFill>
+                <a:latin typeface="Oswald" pitchFamily="34" charset="0"/>
+                <a:ea typeface="Oswald" pitchFamily="34" charset="-122"/>
+                <a:cs typeface="Oswald" pitchFamily="34" charset="-120"/>
+              </a:rPr>
+              <a:t>replicación</a:t>
+            </a:r>
+            <a:r>
+              <a:rPr lang="en-US" sz="3000" b="1" dirty="0">
+                <a:solidFill>
+                  <a:srgbClr val="2E0A4E"/>
+                </a:solidFill>
+                <a:latin typeface="Oswald" pitchFamily="34" charset="0"/>
+                <a:ea typeface="Oswald" pitchFamily="34" charset="-122"/>
+                <a:cs typeface="Oswald" pitchFamily="34" charset="-120"/>
+              </a:rPr>
+              <a:t> (2)</a:t>
+            </a:r>
+            <a:endParaRPr lang="en-US" sz="3000" dirty="0"/>
+          </a:p>
+        </p:txBody>
+      </p:sp>
+      <p:sp>
+        <p:nvSpPr>
+          <p:cNvPr id="5" name="Shape 3"/>
+          <p:cNvSpPr/>
+          <p:nvPr/>
+        </p:nvSpPr>
+        <p:spPr>
+          <a:xfrm>
+            <a:off x="502920" y="1188720"/>
+            <a:ext cx="3954780" cy="585216"/>
+          </a:xfrm>
+          <a:prstGeom prst="roundRect">
+            <a:avLst>
+              <a:gd name="adj" fmla="val 7813"/>
+            </a:avLst>
+          </a:prstGeom>
+          <a:solidFill>
+            <a:schemeClr val="accent1">
+              <a:lumMod val="20000"/>
+              <a:lumOff val="80000"/>
+            </a:schemeClr>
+          </a:solidFill>
+          <a:ln w="12700">
+            <a:solidFill>
+              <a:srgbClr val="F4ECFB"/>
+            </a:solidFill>
+            <a:prstDash val="solid"/>
+          </a:ln>
+        </p:spPr>
+        <p:txBody>
+          <a:bodyPr/>
+          <a:lstStyle/>
+          <a:p>
+            <a:endParaRPr lang="en-US"/>
+          </a:p>
+        </p:txBody>
+      </p:sp>
+      <p:sp>
+        <p:nvSpPr>
+          <p:cNvPr id="6" name="Text 4"/>
+          <p:cNvSpPr txBox="1"/>
+          <p:nvPr/>
+        </p:nvSpPr>
+        <p:spPr>
+          <a:xfrm>
+            <a:off x="640080" y="1207008"/>
+            <a:ext cx="3680460" cy="292608"/>
+          </a:xfrm>
+          <a:prstGeom prst="rect">
+            <a:avLst/>
+          </a:prstGeom>
+          <a:noFill/>
+          <a:ln/>
+        </p:spPr>
+        <p:txBody>
+          <a:bodyPr wrap="square" lIns="0" tIns="0" rIns="0" bIns="0" rtlCol="0" anchor="ctr"/>
+          <a:lstStyle/>
+          <a:p>
+            <a:pPr marL="0" indent="0">
+              <a:buNone/>
+            </a:pPr>
+            <a:r>
+              <a:rPr lang="en-US" sz="1050" b="1" dirty="0">
+                <a:solidFill>
+                  <a:srgbClr val="5A189A"/>
+                </a:solidFill>
+                <a:latin typeface="Courier New" pitchFamily="34" charset="0"/>
+                <a:ea typeface="Courier New" pitchFamily="34" charset="-122"/>
+                <a:cs typeface="Courier New" pitchFamily="34" charset="-120"/>
+              </a:rPr>
+              <a:t>layout_columns(col_widths = 6)</a:t>
+            </a:r>
+            <a:endParaRPr lang="en-US" sz="1050" dirty="0"/>
+          </a:p>
+        </p:txBody>
+      </p:sp>
+      <p:sp>
+        <p:nvSpPr>
+          <p:cNvPr id="7" name="Text 5"/>
+          <p:cNvSpPr txBox="1"/>
+          <p:nvPr/>
+        </p:nvSpPr>
+        <p:spPr>
+          <a:xfrm>
+            <a:off x="640080" y="1469624"/>
+            <a:ext cx="3680460" cy="292608"/>
+          </a:xfrm>
+          <a:prstGeom prst="rect">
+            <a:avLst/>
+          </a:prstGeom>
+          <a:noFill/>
+          <a:ln/>
+        </p:spPr>
+        <p:txBody>
+          <a:bodyPr wrap="square" lIns="0" tIns="0" rIns="0" bIns="0" rtlCol="0" anchor="ctr"/>
+          <a:lstStyle/>
+          <a:p>
+            <a:pPr marL="0" indent="0">
+              <a:buNone/>
+            </a:pPr>
+            <a:r>
+              <a:rPr lang="en-US" sz="1050" dirty="0">
+                <a:solidFill>
+                  <a:srgbClr val="2E0A4E"/>
+                </a:solidFill>
+                <a:latin typeface="Calibri" pitchFamily="34" charset="0"/>
+                <a:ea typeface="Calibri" pitchFamily="34" charset="-122"/>
+                <a:cs typeface="Calibri" pitchFamily="34" charset="-120"/>
+              </a:rPr>
+              <a:t>Tarjetas de a dos por fila.</a:t>
+            </a:r>
+            <a:endParaRPr lang="en-US" sz="1050" dirty="0"/>
+          </a:p>
+        </p:txBody>
+      </p:sp>
+      <p:sp>
+        <p:nvSpPr>
+          <p:cNvPr id="8" name="Shape 6"/>
+          <p:cNvSpPr/>
+          <p:nvPr/>
+        </p:nvSpPr>
+        <p:spPr>
+          <a:xfrm>
+            <a:off x="4675751" y="1609344"/>
+            <a:ext cx="3954780" cy="585216"/>
+          </a:xfrm>
+          <a:prstGeom prst="roundRect">
+            <a:avLst>
+              <a:gd name="adj" fmla="val 7813"/>
+            </a:avLst>
+          </a:prstGeom>
+          <a:solidFill>
+            <a:schemeClr val="accent4">
+              <a:lumMod val="20000"/>
+              <a:lumOff val="80000"/>
+            </a:schemeClr>
+          </a:solidFill>
+          <a:ln w="12700">
+            <a:solidFill>
+              <a:srgbClr val="F4ECFB"/>
+            </a:solidFill>
+            <a:prstDash val="solid"/>
+          </a:ln>
+        </p:spPr>
+        <p:txBody>
+          <a:bodyPr/>
+          <a:lstStyle/>
+          <a:p>
+            <a:endParaRPr lang="en-US"/>
+          </a:p>
+        </p:txBody>
+      </p:sp>
+      <p:sp>
+        <p:nvSpPr>
+          <p:cNvPr id="9" name="Text 7"/>
+          <p:cNvSpPr txBox="1"/>
+          <p:nvPr/>
+        </p:nvSpPr>
+        <p:spPr>
+          <a:xfrm>
+            <a:off x="4812911" y="1627632"/>
+            <a:ext cx="3680460" cy="292608"/>
+          </a:xfrm>
+          <a:prstGeom prst="rect">
+            <a:avLst/>
+          </a:prstGeom>
+          <a:noFill/>
+          <a:ln/>
+        </p:spPr>
+        <p:txBody>
+          <a:bodyPr wrap="square" lIns="0" tIns="0" rIns="0" bIns="0" rtlCol="0" anchor="ctr"/>
+          <a:lstStyle/>
+          <a:p>
+            <a:pPr marL="0" indent="0">
+              <a:buNone/>
+            </a:pPr>
+            <a:r>
+              <a:rPr lang="en-US" sz="1050" b="1" dirty="0">
+                <a:solidFill>
+                  <a:srgbClr val="5A189A"/>
+                </a:solidFill>
+                <a:latin typeface="Courier New" pitchFamily="34" charset="0"/>
+                <a:ea typeface="Courier New" pitchFamily="34" charset="-122"/>
+                <a:cs typeface="Courier New" pitchFamily="34" charset="-120"/>
+              </a:rPr>
+              <a:t>leaflet() y addProviderTiles()</a:t>
+            </a:r>
+            <a:endParaRPr lang="en-US" sz="1050" dirty="0"/>
+          </a:p>
+        </p:txBody>
+      </p:sp>
+      <p:sp>
+        <p:nvSpPr>
+          <p:cNvPr id="10" name="Text 8"/>
+          <p:cNvSpPr txBox="1"/>
+          <p:nvPr/>
+        </p:nvSpPr>
+        <p:spPr>
+          <a:xfrm>
+            <a:off x="4812911" y="1890248"/>
+            <a:ext cx="3680460" cy="292608"/>
+          </a:xfrm>
+          <a:prstGeom prst="rect">
+            <a:avLst/>
+          </a:prstGeom>
+          <a:noFill/>
+          <a:ln/>
+        </p:spPr>
+        <p:txBody>
+          <a:bodyPr wrap="square" lIns="0" tIns="0" rIns="0" bIns="0" rtlCol="0" anchor="ctr"/>
+          <a:lstStyle/>
+          <a:p>
+            <a:pPr marL="0" indent="0">
+              <a:buNone/>
+            </a:pPr>
+            <a:r>
+              <a:rPr lang="en-US" sz="1050" dirty="0">
+                <a:solidFill>
+                  <a:srgbClr val="2E0A4E"/>
+                </a:solidFill>
+                <a:latin typeface="Calibri" pitchFamily="34" charset="0"/>
+                <a:ea typeface="Calibri" pitchFamily="34" charset="-122"/>
+                <a:cs typeface="Calibri" pitchFamily="34" charset="-120"/>
+              </a:rPr>
+              <a:t>El mapa y su fondo.</a:t>
+            </a:r>
+            <a:endParaRPr lang="en-US" sz="1050" dirty="0"/>
+          </a:p>
+        </p:txBody>
+      </p:sp>
+      <p:sp>
+        <p:nvSpPr>
+          <p:cNvPr id="11" name="Shape 9"/>
+          <p:cNvSpPr/>
+          <p:nvPr/>
+        </p:nvSpPr>
+        <p:spPr>
+          <a:xfrm>
+            <a:off x="502920" y="1847088"/>
+            <a:ext cx="3954780" cy="585216"/>
+          </a:xfrm>
+          <a:prstGeom prst="roundRect">
+            <a:avLst>
+              <a:gd name="adj" fmla="val 7813"/>
+            </a:avLst>
+          </a:prstGeom>
+          <a:solidFill>
+            <a:schemeClr val="accent1">
+              <a:lumMod val="20000"/>
+              <a:lumOff val="80000"/>
+            </a:schemeClr>
+          </a:solidFill>
+          <a:ln w="12700">
+            <a:solidFill>
+              <a:srgbClr val="F4ECFB"/>
+            </a:solidFill>
+            <a:prstDash val="solid"/>
+          </a:ln>
+        </p:spPr>
+        <p:txBody>
+          <a:bodyPr/>
+          <a:lstStyle/>
+          <a:p>
+            <a:endParaRPr lang="en-US"/>
+          </a:p>
+        </p:txBody>
+      </p:sp>
+      <p:sp>
+        <p:nvSpPr>
+          <p:cNvPr id="12" name="Text 10"/>
+          <p:cNvSpPr txBox="1"/>
+          <p:nvPr/>
+        </p:nvSpPr>
+        <p:spPr>
+          <a:xfrm>
+            <a:off x="640080" y="1865376"/>
+            <a:ext cx="3680460" cy="292608"/>
+          </a:xfrm>
+          <a:prstGeom prst="rect">
+            <a:avLst/>
+          </a:prstGeom>
+          <a:noFill/>
+          <a:ln/>
+        </p:spPr>
+        <p:txBody>
+          <a:bodyPr wrap="square" lIns="0" tIns="0" rIns="0" bIns="0" rtlCol="0" anchor="ctr"/>
+          <a:lstStyle/>
+          <a:p>
+            <a:pPr marL="0" indent="0">
+              <a:buNone/>
+            </a:pPr>
+            <a:r>
+              <a:rPr lang="en-US" sz="1050" b="1" dirty="0">
+                <a:solidFill>
+                  <a:srgbClr val="5A189A"/>
+                </a:solidFill>
+                <a:latin typeface="Courier New" pitchFamily="34" charset="0"/>
+                <a:ea typeface="Courier New" pitchFamily="34" charset="-122"/>
+                <a:cs typeface="Courier New" pitchFamily="34" charset="-120"/>
+              </a:rPr>
+              <a:t>addCircleMarkers()</a:t>
+            </a:r>
+            <a:endParaRPr lang="en-US" sz="1050" dirty="0"/>
+          </a:p>
+        </p:txBody>
+      </p:sp>
+      <p:sp>
+        <p:nvSpPr>
+          <p:cNvPr id="13" name="Text 11"/>
+          <p:cNvSpPr txBox="1"/>
+          <p:nvPr/>
+        </p:nvSpPr>
+        <p:spPr>
+          <a:xfrm>
+            <a:off x="640080" y="2127992"/>
+            <a:ext cx="3680460" cy="292608"/>
+          </a:xfrm>
+          <a:prstGeom prst="rect">
+            <a:avLst/>
+          </a:prstGeom>
+          <a:noFill/>
+          <a:ln/>
+        </p:spPr>
+        <p:txBody>
+          <a:bodyPr wrap="square" lIns="0" tIns="0" rIns="0" bIns="0" rtlCol="0" anchor="ctr"/>
+          <a:lstStyle/>
+          <a:p>
+            <a:pPr marL="0" indent="0">
+              <a:buNone/>
+            </a:pPr>
+            <a:r>
+              <a:rPr lang="en-US" sz="1050" dirty="0">
+                <a:solidFill>
+                  <a:srgbClr val="2E0A4E"/>
+                </a:solidFill>
+                <a:latin typeface="Calibri" pitchFamily="34" charset="0"/>
+                <a:ea typeface="Calibri" pitchFamily="34" charset="-122"/>
+                <a:cs typeface="Calibri" pitchFamily="34" charset="-120"/>
+              </a:rPr>
+              <a:t>Un círculo por local, en Longitud y Latitud.</a:t>
+            </a:r>
+            <a:endParaRPr lang="en-US" sz="1050" dirty="0"/>
+          </a:p>
+        </p:txBody>
+      </p:sp>
+      <p:sp>
+        <p:nvSpPr>
+          <p:cNvPr id="14" name="Shape 12"/>
+          <p:cNvSpPr/>
+          <p:nvPr/>
+        </p:nvSpPr>
+        <p:spPr>
+          <a:xfrm>
+            <a:off x="4675751" y="2267712"/>
+            <a:ext cx="3954780" cy="585216"/>
+          </a:xfrm>
+          <a:prstGeom prst="roundRect">
+            <a:avLst>
+              <a:gd name="adj" fmla="val 7813"/>
+            </a:avLst>
+          </a:prstGeom>
+          <a:solidFill>
+            <a:schemeClr val="accent4">
+              <a:lumMod val="20000"/>
+              <a:lumOff val="80000"/>
+            </a:schemeClr>
+          </a:solidFill>
+          <a:ln w="12700">
+            <a:solidFill>
+              <a:srgbClr val="F4ECFB"/>
+            </a:solidFill>
+            <a:prstDash val="solid"/>
+          </a:ln>
+        </p:spPr>
+        <p:txBody>
+          <a:bodyPr/>
+          <a:lstStyle/>
+          <a:p>
+            <a:endParaRPr lang="en-US"/>
+          </a:p>
+        </p:txBody>
+      </p:sp>
+      <p:sp>
+        <p:nvSpPr>
+          <p:cNvPr id="15" name="Text 13"/>
+          <p:cNvSpPr txBox="1"/>
+          <p:nvPr/>
+        </p:nvSpPr>
+        <p:spPr>
+          <a:xfrm>
+            <a:off x="4812911" y="2286000"/>
+            <a:ext cx="3680460" cy="292608"/>
+          </a:xfrm>
+          <a:prstGeom prst="rect">
+            <a:avLst/>
+          </a:prstGeom>
+          <a:noFill/>
+          <a:ln/>
+        </p:spPr>
+        <p:txBody>
+          <a:bodyPr wrap="square" lIns="0" tIns="0" rIns="0" bIns="0" rtlCol="0" anchor="ctr"/>
+          <a:lstStyle/>
+          <a:p>
+            <a:pPr marL="0" indent="0">
+              <a:buNone/>
+            </a:pPr>
+            <a:r>
+              <a:rPr lang="en-US" sz="1050" b="1" dirty="0">
+                <a:solidFill>
+                  <a:srgbClr val="5A189A"/>
+                </a:solidFill>
+                <a:latin typeface="Courier New" pitchFamily="34" charset="0"/>
+                <a:ea typeface="Courier New" pitchFamily="34" charset="-122"/>
+                <a:cs typeface="Courier New" pitchFamily="34" charset="-120"/>
+              </a:rPr>
+              <a:t>colorFactor() y colorNumeric()</a:t>
+            </a:r>
+            <a:endParaRPr lang="en-US" sz="1050" dirty="0"/>
+          </a:p>
+        </p:txBody>
+      </p:sp>
+      <p:sp>
+        <p:nvSpPr>
+          <p:cNvPr id="16" name="Text 14"/>
+          <p:cNvSpPr txBox="1"/>
+          <p:nvPr/>
+        </p:nvSpPr>
+        <p:spPr>
+          <a:xfrm>
+            <a:off x="4812911" y="2548616"/>
+            <a:ext cx="3680460" cy="292608"/>
+          </a:xfrm>
+          <a:prstGeom prst="rect">
+            <a:avLst/>
+          </a:prstGeom>
+          <a:noFill/>
+          <a:ln/>
+        </p:spPr>
+        <p:txBody>
+          <a:bodyPr wrap="square" lIns="0" tIns="0" rIns="0" bIns="0" rtlCol="0" anchor="ctr"/>
+          <a:lstStyle/>
+          <a:p>
+            <a:pPr marL="0" indent="0">
+              <a:buNone/>
+            </a:pPr>
+            <a:r>
+              <a:rPr lang="en-US" sz="1050" dirty="0">
+                <a:solidFill>
+                  <a:srgbClr val="2E0A4E"/>
+                </a:solidFill>
+                <a:latin typeface="Calibri" pitchFamily="34" charset="0"/>
+                <a:ea typeface="Calibri" pitchFamily="34" charset="-122"/>
+                <a:cs typeface="Calibri" pitchFamily="34" charset="-120"/>
+              </a:rPr>
+              <a:t>Escalas de color por categoría o por número.</a:t>
+            </a:r>
+            <a:endParaRPr lang="en-US" sz="1050" dirty="0"/>
+          </a:p>
+        </p:txBody>
+      </p:sp>
+      <p:sp>
+        <p:nvSpPr>
+          <p:cNvPr id="17" name="Shape 15"/>
+          <p:cNvSpPr/>
+          <p:nvPr/>
+        </p:nvSpPr>
+        <p:spPr>
+          <a:xfrm>
+            <a:off x="502920" y="2505456"/>
+            <a:ext cx="3954780" cy="585216"/>
+          </a:xfrm>
+          <a:prstGeom prst="roundRect">
+            <a:avLst>
+              <a:gd name="adj" fmla="val 7813"/>
+            </a:avLst>
+          </a:prstGeom>
+          <a:solidFill>
+            <a:schemeClr val="accent1">
+              <a:lumMod val="20000"/>
+              <a:lumOff val="80000"/>
+            </a:schemeClr>
+          </a:solidFill>
+          <a:ln w="12700">
+            <a:solidFill>
+              <a:srgbClr val="F4ECFB"/>
+            </a:solidFill>
+            <a:prstDash val="solid"/>
+          </a:ln>
+        </p:spPr>
+        <p:txBody>
+          <a:bodyPr/>
+          <a:lstStyle/>
+          <a:p>
+            <a:endParaRPr lang="en-US"/>
+          </a:p>
+        </p:txBody>
+      </p:sp>
+      <p:sp>
+        <p:nvSpPr>
+          <p:cNvPr id="18" name="Text 16"/>
+          <p:cNvSpPr txBox="1"/>
+          <p:nvPr/>
+        </p:nvSpPr>
+        <p:spPr>
+          <a:xfrm>
+            <a:off x="640080" y="2523744"/>
+            <a:ext cx="3680460" cy="292608"/>
+          </a:xfrm>
+          <a:prstGeom prst="rect">
+            <a:avLst/>
+          </a:prstGeom>
+          <a:noFill/>
+          <a:ln/>
+        </p:spPr>
+        <p:txBody>
+          <a:bodyPr wrap="square" lIns="0" tIns="0" rIns="0" bIns="0" rtlCol="0" anchor="ctr"/>
+          <a:lstStyle/>
+          <a:p>
+            <a:pPr marL="0" indent="0">
+              <a:buNone/>
+            </a:pPr>
+            <a:r>
+              <a:rPr lang="en-US" sz="1050" b="1" dirty="0">
+                <a:solidFill>
+                  <a:srgbClr val="5A189A"/>
+                </a:solidFill>
+                <a:latin typeface="Courier New" pitchFamily="34" charset="0"/>
+                <a:ea typeface="Courier New" pitchFamily="34" charset="-122"/>
+                <a:cs typeface="Courier New" pitchFamily="34" charset="-120"/>
+              </a:rPr>
+              <a:t>aggregate()</a:t>
+            </a:r>
+            <a:endParaRPr lang="en-US" sz="1050" dirty="0"/>
+          </a:p>
+        </p:txBody>
+      </p:sp>
+      <p:sp>
+        <p:nvSpPr>
+          <p:cNvPr id="19" name="Text 17"/>
+          <p:cNvSpPr txBox="1"/>
+          <p:nvPr/>
+        </p:nvSpPr>
+        <p:spPr>
+          <a:xfrm>
+            <a:off x="640080" y="2786360"/>
+            <a:ext cx="3680460" cy="292608"/>
+          </a:xfrm>
+          <a:prstGeom prst="rect">
+            <a:avLst/>
+          </a:prstGeom>
+          <a:noFill/>
+          <a:ln/>
+        </p:spPr>
+        <p:txBody>
+          <a:bodyPr wrap="square" lIns="0" tIns="0" rIns="0" bIns="0" rtlCol="0" anchor="ctr"/>
+          <a:lstStyle/>
+          <a:p>
+            <a:pPr marL="0" indent="0">
+              <a:buNone/>
+            </a:pPr>
+            <a:r>
+              <a:rPr lang="en-US" sz="1050" dirty="0">
+                <a:solidFill>
+                  <a:srgbClr val="2E0A4E"/>
+                </a:solidFill>
+                <a:latin typeface="Calibri" pitchFamily="34" charset="0"/>
+                <a:ea typeface="Calibri" pitchFamily="34" charset="-122"/>
+                <a:cs typeface="Calibri" pitchFamily="34" charset="-120"/>
+              </a:rPr>
+              <a:t>Suma columnas por grupo, por región.</a:t>
+            </a:r>
+            <a:endParaRPr lang="en-US" sz="1050" dirty="0"/>
+          </a:p>
+        </p:txBody>
+      </p:sp>
+      <p:sp>
+        <p:nvSpPr>
+          <p:cNvPr id="20" name="Shape 18"/>
+          <p:cNvSpPr/>
+          <p:nvPr/>
+        </p:nvSpPr>
+        <p:spPr>
+          <a:xfrm>
+            <a:off x="4675751" y="2926080"/>
+            <a:ext cx="3954780" cy="585216"/>
+          </a:xfrm>
+          <a:prstGeom prst="roundRect">
+            <a:avLst>
+              <a:gd name="adj" fmla="val 7813"/>
+            </a:avLst>
+          </a:prstGeom>
+          <a:solidFill>
+            <a:schemeClr val="accent4">
+              <a:lumMod val="20000"/>
+              <a:lumOff val="80000"/>
+            </a:schemeClr>
+          </a:solidFill>
+          <a:ln w="12700">
+            <a:solidFill>
+              <a:srgbClr val="F4ECFB"/>
+            </a:solidFill>
+            <a:prstDash val="solid"/>
+          </a:ln>
+        </p:spPr>
+        <p:txBody>
+          <a:bodyPr/>
+          <a:lstStyle/>
+          <a:p>
+            <a:endParaRPr lang="en-US"/>
+          </a:p>
+        </p:txBody>
+      </p:sp>
+      <p:sp>
+        <p:nvSpPr>
+          <p:cNvPr id="21" name="Text 19"/>
+          <p:cNvSpPr txBox="1"/>
+          <p:nvPr/>
+        </p:nvSpPr>
+        <p:spPr>
+          <a:xfrm>
+            <a:off x="4812911" y="2944368"/>
+            <a:ext cx="3680460" cy="292608"/>
+          </a:xfrm>
+          <a:prstGeom prst="rect">
+            <a:avLst/>
+          </a:prstGeom>
+          <a:noFill/>
+          <a:ln/>
+        </p:spPr>
+        <p:txBody>
+          <a:bodyPr wrap="square" lIns="0" tIns="0" rIns="0" bIns="0" rtlCol="0" anchor="ctr"/>
+          <a:lstStyle/>
+          <a:p>
+            <a:pPr marL="0" indent="0">
+              <a:buNone/>
+            </a:pPr>
+            <a:r>
+              <a:rPr lang="en-US" sz="1050" b="1" dirty="0">
+                <a:solidFill>
+                  <a:srgbClr val="5A189A"/>
+                </a:solidFill>
+                <a:latin typeface="Courier New" pitchFamily="34" charset="0"/>
+                <a:ea typeface="Courier New" pitchFamily="34" charset="-122"/>
+                <a:cs typeface="Courier New" pitchFamily="34" charset="-120"/>
+              </a:rPr>
+              <a:t>options(shiny.sanitize.errors)</a:t>
+            </a:r>
+            <a:endParaRPr lang="en-US" sz="1050" dirty="0"/>
+          </a:p>
+        </p:txBody>
+      </p:sp>
+      <p:sp>
+        <p:nvSpPr>
+          <p:cNvPr id="22" name="Text 20"/>
+          <p:cNvSpPr txBox="1"/>
+          <p:nvPr/>
+        </p:nvSpPr>
+        <p:spPr>
+          <a:xfrm>
+            <a:off x="4812911" y="3206984"/>
+            <a:ext cx="3680460" cy="292608"/>
+          </a:xfrm>
+          <a:prstGeom prst="rect">
+            <a:avLst/>
+          </a:prstGeom>
+          <a:noFill/>
+          <a:ln/>
+        </p:spPr>
+        <p:txBody>
+          <a:bodyPr wrap="square" lIns="0" tIns="0" rIns="0" bIns="0" rtlCol="0" anchor="ctr"/>
+          <a:lstStyle/>
+          <a:p>
+            <a:pPr marL="0" indent="0">
+              <a:buNone/>
+            </a:pPr>
+            <a:r>
+              <a:rPr lang="en-US" sz="1050" dirty="0">
+                <a:solidFill>
+                  <a:srgbClr val="2E0A4E"/>
+                </a:solidFill>
+                <a:latin typeface="Calibri" pitchFamily="34" charset="0"/>
+                <a:ea typeface="Calibri" pitchFamily="34" charset="-122"/>
+                <a:cs typeface="Calibri" pitchFamily="34" charset="-120"/>
+              </a:rPr>
+              <a:t>Esconde el detalle de los errores al publicar.</a:t>
+            </a:r>
+            <a:endParaRPr lang="en-US" sz="1050" dirty="0"/>
+          </a:p>
+        </p:txBody>
+      </p:sp>
+      <p:sp>
+        <p:nvSpPr>
+          <p:cNvPr id="23" name="Shape 21"/>
+          <p:cNvSpPr/>
+          <p:nvPr/>
+        </p:nvSpPr>
+        <p:spPr>
+          <a:xfrm>
+            <a:off x="502920" y="3163824"/>
+            <a:ext cx="3954780" cy="585216"/>
+          </a:xfrm>
+          <a:prstGeom prst="roundRect">
+            <a:avLst>
+              <a:gd name="adj" fmla="val 7813"/>
+            </a:avLst>
+          </a:prstGeom>
+          <a:solidFill>
+            <a:schemeClr val="accent1">
+              <a:lumMod val="20000"/>
+              <a:lumOff val="80000"/>
+            </a:schemeClr>
+          </a:solidFill>
+          <a:ln w="12700">
+            <a:solidFill>
+              <a:srgbClr val="F4ECFB"/>
+            </a:solidFill>
+            <a:prstDash val="solid"/>
+          </a:ln>
+        </p:spPr>
+        <p:txBody>
+          <a:bodyPr/>
+          <a:lstStyle/>
+          <a:p>
+            <a:endParaRPr lang="en-US"/>
+          </a:p>
+        </p:txBody>
+      </p:sp>
+      <p:sp>
+        <p:nvSpPr>
+          <p:cNvPr id="24" name="Text 22"/>
+          <p:cNvSpPr txBox="1"/>
+          <p:nvPr/>
+        </p:nvSpPr>
+        <p:spPr>
+          <a:xfrm>
+            <a:off x="640080" y="3182112"/>
+            <a:ext cx="3680460" cy="292608"/>
+          </a:xfrm>
+          <a:prstGeom prst="rect">
+            <a:avLst/>
+          </a:prstGeom>
+          <a:noFill/>
+          <a:ln/>
+        </p:spPr>
+        <p:txBody>
+          <a:bodyPr wrap="square" lIns="0" tIns="0" rIns="0" bIns="0" rtlCol="0" anchor="ctr"/>
+          <a:lstStyle/>
+          <a:p>
+            <a:pPr marL="0" indent="0">
+              <a:buNone/>
+            </a:pPr>
+            <a:r>
+              <a:rPr lang="en-US" sz="1050" b="1" dirty="0">
+                <a:solidFill>
+                  <a:srgbClr val="5A189A"/>
+                </a:solidFill>
+                <a:latin typeface="Courier New" pitchFamily="34" charset="0"/>
+                <a:ea typeface="Courier New" pitchFamily="34" charset="-122"/>
+                <a:cs typeface="Courier New" pitchFamily="34" charset="-120"/>
+              </a:rPr>
+              <a:t>rsconnect::deployApp()</a:t>
+            </a:r>
+            <a:endParaRPr lang="en-US" sz="1050" dirty="0"/>
+          </a:p>
+        </p:txBody>
+      </p:sp>
+      <p:sp>
+        <p:nvSpPr>
+          <p:cNvPr id="25" name="Text 23"/>
+          <p:cNvSpPr txBox="1"/>
+          <p:nvPr/>
+        </p:nvSpPr>
+        <p:spPr>
+          <a:xfrm>
+            <a:off x="640080" y="3444728"/>
+            <a:ext cx="3680460" cy="292608"/>
+          </a:xfrm>
+          <a:prstGeom prst="rect">
+            <a:avLst/>
+          </a:prstGeom>
+          <a:noFill/>
+          <a:ln/>
+        </p:spPr>
+        <p:txBody>
+          <a:bodyPr wrap="square" lIns="0" tIns="0" rIns="0" bIns="0" rtlCol="0" anchor="ctr"/>
+          <a:lstStyle/>
+          <a:p>
+            <a:pPr marL="0" indent="0">
+              <a:buNone/>
+            </a:pPr>
+            <a:r>
+              <a:rPr lang="en-US" sz="1050" dirty="0">
+                <a:solidFill>
+                  <a:srgbClr val="2E0A4E"/>
+                </a:solidFill>
+                <a:latin typeface="Calibri" pitchFamily="34" charset="0"/>
+                <a:ea typeface="Calibri" pitchFamily="34" charset="-122"/>
+                <a:cs typeface="Calibri" pitchFamily="34" charset="-120"/>
+              </a:rPr>
+              <a:t>Publica la app en shinyapps.io.</a:t>
+            </a:r>
+            <a:endParaRPr lang="en-US" sz="1050" dirty="0"/>
+          </a:p>
+        </p:txBody>
+      </p:sp>
+    </p:spTree>
+  </p:cSld>
+  <p:clrMapOvr>
+    <a:masterClrMapping/>
+  </p:clrMapOvr>
+</p:sld>
+</file>
+
+<file path=ppt/slides/slide15.xml><?xml version="1.0" encoding="utf-8"?>
+<p:sld xmlns:a="http://schemas.openxmlformats.org/drawingml/2006/main" xmlns:p="http://schemas.openxmlformats.org/presentationml/2006/main" xmlns:r="http://schemas.openxmlformats.org/officeDocument/2006/relationships">
+  <p:cSld>
+    <p:bg>
+      <p:bgPr>
+        <a:solidFill>
+          <a:srgbClr val="FFFFFF"/>
+        </a:solidFill>
+        <a:effectLst/>
+      </p:bgPr>
+    </p:bg>
+    <p:spTree>
+      <p:nvGrpSpPr>
+        <p:cNvPr id="1" name=""/>
+        <p:cNvGrpSpPr/>
+        <p:nvPr/>
+      </p:nvGrpSpPr>
+      <p:grpSpPr/>
+      <p:sp>
+        <p:nvSpPr>
+          <p:cNvPr id="2" name="Text 0"/>
+          <p:cNvSpPr txBox="1"/>
+          <p:nvPr/>
+        </p:nvSpPr>
+        <p:spPr>
+          <a:xfrm>
+            <a:off x="502920" y="320040"/>
+            <a:ext cx="7040880" cy="640080"/>
+          </a:xfrm>
+          <a:prstGeom prst="rect">
+            <a:avLst/>
+          </a:prstGeom>
+          <a:noFill/>
+          <a:ln/>
+        </p:spPr>
+        <p:txBody>
+          <a:bodyPr wrap="square" lIns="0" tIns="0" rIns="0" bIns="0" rtlCol="0" anchor="ctr"/>
+          <a:lstStyle/>
+          <a:p>
+            <a:pPr marL="0" indent="0">
+              <a:buNone/>
+            </a:pPr>
+            <a:r>
+              <a:rPr lang="en-US" sz="3000" b="1" dirty="0">
+                <a:solidFill>
+                  <a:srgbClr val="2E0A4E"/>
+                </a:solidFill>
+                <a:latin typeface="Oswald" pitchFamily="34" charset="0"/>
+                <a:ea typeface="Oswald" pitchFamily="34" charset="-122"/>
+                <a:cs typeface="Oswald" pitchFamily="34" charset="-120"/>
+              </a:rPr>
+              <a:t>Código clave (2)</a:t>
+            </a:r>
+            <a:endParaRPr lang="en-US" sz="3000" dirty="0"/>
+          </a:p>
+        </p:txBody>
+      </p:sp>
+      <p:sp>
+        <p:nvSpPr>
+          <p:cNvPr id="3" name="Text 1"/>
+          <p:cNvSpPr txBox="1"/>
+          <p:nvPr/>
+        </p:nvSpPr>
+        <p:spPr>
+          <a:xfrm>
+            <a:off x="7543800" y="320040"/>
+            <a:ext cx="1097280" cy="640080"/>
+          </a:xfrm>
+          <a:prstGeom prst="rect">
+            <a:avLst/>
+          </a:prstGeom>
+          <a:noFill/>
+          <a:ln/>
+        </p:spPr>
+        <p:txBody>
+          <a:bodyPr wrap="square" lIns="0" tIns="0" rIns="0" bIns="0" rtlCol="0" anchor="ctr"/>
+          <a:lstStyle/>
+          <a:p>
+            <a:pPr marL="0" indent="0" algn="r">
+              <a:buNone/>
+            </a:pPr>
+            <a:r>
+              <a:rPr lang="en-US" sz="1600" dirty="0">
+                <a:solidFill>
+                  <a:srgbClr val="9D4EDD"/>
+                </a:solidFill>
+                <a:latin typeface="Oswald" pitchFamily="34" charset="0"/>
+                <a:ea typeface="Oswald" pitchFamily="34" charset="-122"/>
+                <a:cs typeface="Oswald" pitchFamily="34" charset="-120"/>
+              </a:rPr>
+              <a:t>Clase 7</a:t>
+            </a:r>
+            <a:endParaRPr lang="en-US" sz="1600" dirty="0"/>
+          </a:p>
+        </p:txBody>
+      </p:sp>
+      <p:sp>
+        <p:nvSpPr>
+          <p:cNvPr id="4" name="Text 2"/>
+          <p:cNvSpPr txBox="1"/>
+          <p:nvPr/>
+        </p:nvSpPr>
+        <p:spPr>
+          <a:xfrm>
+            <a:off x="502920" y="4759452"/>
+            <a:ext cx="8138160" cy="228600"/>
+          </a:xfrm>
+          <a:prstGeom prst="rect">
+            <a:avLst/>
+          </a:prstGeom>
+          <a:noFill/>
+          <a:ln/>
+        </p:spPr>
+        <p:txBody>
+          <a:bodyPr wrap="square" lIns="0" tIns="0" rIns="0" bIns="0" rtlCol="0" anchor="ctr"/>
+          <a:lstStyle/>
+          <a:p>
+            <a:pPr marL="0" indent="0">
+              <a:buNone/>
+            </a:pPr>
+            <a:r>
+              <a:rPr lang="en-US" sz="900" dirty="0">
+                <a:solidFill>
+                  <a:srgbClr val="999999"/>
+                </a:solidFill>
+                <a:latin typeface="Calibri" pitchFamily="34" charset="0"/>
+                <a:ea typeface="Calibri" pitchFamily="34" charset="-122"/>
+                <a:cs typeface="Calibri" pitchFamily="34" charset="-120"/>
+              </a:rPr>
+              <a:t>Visualización interactiva de datos con R y Shiny · Udelar</a:t>
+            </a:r>
+            <a:endParaRPr lang="en-US" sz="900" dirty="0"/>
+          </a:p>
+        </p:txBody>
+      </p:sp>
+      <p:sp>
+        <p:nvSpPr>
+          <p:cNvPr id="5" name="Shape 3"/>
+          <p:cNvSpPr/>
+          <p:nvPr/>
+        </p:nvSpPr>
+        <p:spPr>
+          <a:xfrm>
+            <a:off x="502920" y="1188720"/>
+            <a:ext cx="8138160" cy="3429000"/>
+          </a:xfrm>
+          <a:prstGeom prst="roundRect">
+            <a:avLst>
+              <a:gd name="adj" fmla="val 1600"/>
+            </a:avLst>
+          </a:prstGeom>
+          <a:solidFill>
+            <a:srgbClr val="2E0A4E"/>
+          </a:solidFill>
+          <a:ln w="12700">
+            <a:solidFill>
+              <a:srgbClr val="2E0A4E"/>
+            </a:solidFill>
+            <a:prstDash val="solid"/>
+          </a:ln>
+        </p:spPr>
+        <p:txBody>
+          <a:bodyPr/>
+          <a:lstStyle/>
+          <a:p>
+            <a:endParaRPr lang="en-US"/>
+          </a:p>
+        </p:txBody>
+      </p:sp>
+      <p:sp>
+        <p:nvSpPr>
+          <p:cNvPr id="6" name="Text 4"/>
+          <p:cNvSpPr txBox="1"/>
+          <p:nvPr/>
+        </p:nvSpPr>
+        <p:spPr>
+          <a:xfrm>
+            <a:off x="777240" y="1325880"/>
+            <a:ext cx="7589520" cy="3154680"/>
+          </a:xfrm>
+          <a:prstGeom prst="rect">
+            <a:avLst/>
+          </a:prstGeom>
+          <a:noFill/>
+          <a:ln/>
+        </p:spPr>
+        <p:txBody>
+          <a:bodyPr wrap="square" lIns="0" tIns="0" rIns="0" bIns="0" rtlCol="0" anchor="t"/>
+          <a:lstStyle/>
+          <a:p>
+            <a:pPr marL="0" indent="0">
+              <a:spcAft>
+                <a:spcPts val="200"/>
+              </a:spcAft>
+              <a:buNone/>
+            </a:pPr>
+            <a:r>
+              <a:rPr lang="en-US" sz="1100" dirty="0">
+                <a:solidFill>
+                  <a:srgbClr val="F1E9F8"/>
+                </a:solidFill>
+                <a:latin typeface="Courier New" pitchFamily="34" charset="0"/>
+                <a:ea typeface="Courier New" pitchFamily="34" charset="-122"/>
+                <a:cs typeface="Courier New" pitchFamily="34" charset="-120"/>
+              </a:rPr>
+              <a:t>locales_filtrados &lt;- reactive({</a:t>
+            </a:r>
+            <a:endParaRPr lang="en-US" sz="1100" dirty="0"/>
+          </a:p>
+          <a:p>
+            <a:pPr marL="0" indent="0">
+              <a:spcAft>
+                <a:spcPts val="200"/>
+              </a:spcAft>
+              <a:buNone/>
+            </a:pPr>
+            <a:r>
+              <a:rPr lang="en-US" sz="1100" dirty="0">
+                <a:solidFill>
+                  <a:srgbClr val="F1E9F8"/>
+                </a:solidFill>
+                <a:latin typeface="Courier New" pitchFamily="34" charset="0"/>
+                <a:ea typeface="Courier New" pitchFamily="34" charset="-122"/>
+                <a:cs typeface="Courier New" pitchFamily="34" charset="-120"/>
+              </a:rPr>
+              <a:t>  locales[locales$DepartamentoNombre %in% datos()$departamento, ]</a:t>
+            </a:r>
+            <a:endParaRPr lang="en-US" sz="1100" dirty="0"/>
+          </a:p>
+          <a:p>
+            <a:pPr marL="0" indent="0">
+              <a:spcAft>
+                <a:spcPts val="200"/>
+              </a:spcAft>
+              <a:buNone/>
+            </a:pPr>
+            <a:r>
+              <a:rPr lang="en-US" sz="1100" dirty="0">
+                <a:solidFill>
+                  <a:srgbClr val="F1E9F8"/>
+                </a:solidFill>
+                <a:latin typeface="Courier New" pitchFamily="34" charset="0"/>
+                <a:ea typeface="Courier New" pitchFamily="34" charset="-122"/>
+                <a:cs typeface="Courier New" pitchFamily="34" charset="-120"/>
+              </a:rPr>
+              <a:t>})</a:t>
+            </a:r>
+            <a:endParaRPr lang="en-US" sz="1100" dirty="0"/>
+          </a:p>
+          <a:p>
+            <a:pPr marL="0" indent="0">
+              <a:spcAft>
+                <a:spcPts val="200"/>
+              </a:spcAft>
+              <a:buNone/>
+            </a:pPr>
+            <a:r>
+              <a:rPr lang="en-US" sz="1100" dirty="0">
+                <a:solidFill>
+                  <a:srgbClr val="F1E9F8"/>
+                </a:solidFill>
+                <a:latin typeface="Courier New" pitchFamily="34" charset="0"/>
+                <a:ea typeface="Courier New" pitchFamily="34" charset="-122"/>
+                <a:cs typeface="Courier New" pitchFamily="34" charset="-120"/>
+              </a:rPr>
+              <a:t/>
+            </a:r>
+            <a:endParaRPr lang="en-US" sz="1100" dirty="0"/>
+          </a:p>
+          <a:p>
+            <a:pPr marL="0" indent="0">
+              <a:spcAft>
+                <a:spcPts val="200"/>
+              </a:spcAft>
+              <a:buNone/>
+            </a:pPr>
+            <a:r>
+              <a:rPr lang="en-US" sz="1100" dirty="0">
+                <a:solidFill>
+                  <a:srgbClr val="F1E9F8"/>
+                </a:solidFill>
+                <a:latin typeface="Courier New" pitchFamily="34" charset="0"/>
+                <a:ea typeface="Courier New" pitchFamily="34" charset="-122"/>
+                <a:cs typeface="Courier New" pitchFamily="34" charset="-120"/>
+              </a:rPr>
+              <a:t>output$m_fa &lt;- renderLeaflet({</a:t>
+            </a:r>
+            <a:endParaRPr lang="en-US" sz="1100" dirty="0"/>
+          </a:p>
+          <a:p>
+            <a:pPr marL="0" indent="0">
+              <a:spcAft>
+                <a:spcPts val="200"/>
+              </a:spcAft>
+              <a:buNone/>
+            </a:pPr>
+            <a:r>
+              <a:rPr lang="en-US" sz="1100" dirty="0">
+                <a:solidFill>
+                  <a:srgbClr val="F1E9F8"/>
+                </a:solidFill>
+                <a:latin typeface="Courier New" pitchFamily="34" charset="0"/>
+                <a:ea typeface="Courier New" pitchFamily="34" charset="-122"/>
+                <a:cs typeface="Courier New" pitchFamily="34" charset="-120"/>
+              </a:rPr>
+              <a:t>  l &lt;- locales_filtrados()</a:t>
+            </a:r>
+            <a:endParaRPr lang="en-US" sz="1100" dirty="0"/>
+          </a:p>
+          <a:p>
+            <a:pPr marL="0" indent="0">
+              <a:spcAft>
+                <a:spcPts val="200"/>
+              </a:spcAft>
+              <a:buNone/>
+            </a:pPr>
+            <a:r>
+              <a:rPr lang="en-US" sz="1100" dirty="0">
+                <a:solidFill>
+                  <a:srgbClr val="F1E9F8"/>
+                </a:solidFill>
+                <a:latin typeface="Courier New" pitchFamily="34" charset="0"/>
+                <a:ea typeface="Courier New" pitchFamily="34" charset="-122"/>
+                <a:cs typeface="Courier New" pitchFamily="34" charset="-120"/>
+              </a:rPr>
+              <a:t>  colores &lt;- colorNumeric(PALETA_MAPAS, domain = l$Pct_Frente_Amplio)</a:t>
+            </a:r>
+            <a:endParaRPr lang="en-US" sz="1100" dirty="0"/>
+          </a:p>
+          <a:p>
+            <a:pPr marL="0" indent="0">
+              <a:spcAft>
+                <a:spcPts val="200"/>
+              </a:spcAft>
+              <a:buNone/>
+            </a:pPr>
+            <a:r>
+              <a:rPr lang="en-US" sz="1100" dirty="0">
+                <a:solidFill>
+                  <a:srgbClr val="F1E9F8"/>
+                </a:solidFill>
+                <a:latin typeface="Courier New" pitchFamily="34" charset="0"/>
+                <a:ea typeface="Courier New" pitchFamily="34" charset="-122"/>
+                <a:cs typeface="Courier New" pitchFamily="34" charset="-120"/>
+              </a:rPr>
+              <a:t>  leaflet(l) |&gt;</a:t>
+            </a:r>
+            <a:endParaRPr lang="en-US" sz="1100" dirty="0"/>
+          </a:p>
+          <a:p>
+            <a:pPr marL="0" indent="0">
+              <a:spcAft>
+                <a:spcPts val="200"/>
+              </a:spcAft>
+              <a:buNone/>
+            </a:pPr>
+            <a:r>
+              <a:rPr lang="en-US" sz="1100" dirty="0">
+                <a:solidFill>
+                  <a:srgbClr val="F1E9F8"/>
+                </a:solidFill>
+                <a:latin typeface="Courier New" pitchFamily="34" charset="0"/>
+                <a:ea typeface="Courier New" pitchFamily="34" charset="-122"/>
+                <a:cs typeface="Courier New" pitchFamily="34" charset="-120"/>
+              </a:rPr>
+              <a:t>    addProviderTiles(FONDO_MAPA) |&gt;</a:t>
+            </a:r>
+            <a:endParaRPr lang="en-US" sz="1100" dirty="0"/>
+          </a:p>
+          <a:p>
+            <a:pPr marL="0" indent="0">
+              <a:spcAft>
+                <a:spcPts val="200"/>
+              </a:spcAft>
+              <a:buNone/>
+            </a:pPr>
+            <a:r>
+              <a:rPr lang="en-US" sz="1100" dirty="0">
+                <a:solidFill>
+                  <a:srgbClr val="F1E9F8"/>
+                </a:solidFill>
+                <a:latin typeface="Courier New" pitchFamily="34" charset="0"/>
+                <a:ea typeface="Courier New" pitchFamily="34" charset="-122"/>
+                <a:cs typeface="Courier New" pitchFamily="34" charset="-120"/>
+              </a:rPr>
+              <a:t>    addCircleMarkers(lng = ~Longitud, lat = ~Latitud, label = ~NombreLocal,</a:t>
+            </a:r>
+            <a:endParaRPr lang="en-US" sz="1100" dirty="0"/>
+          </a:p>
+          <a:p>
+            <a:pPr marL="0" indent="0">
+              <a:spcAft>
+                <a:spcPts val="200"/>
+              </a:spcAft>
+              <a:buNone/>
+            </a:pPr>
+            <a:r>
+              <a:rPr lang="en-US" sz="1100" dirty="0">
+                <a:solidFill>
+                  <a:srgbClr val="F1E9F8"/>
+                </a:solidFill>
+                <a:latin typeface="Courier New" pitchFamily="34" charset="0"/>
+                <a:ea typeface="Courier New" pitchFamily="34" charset="-122"/>
+                <a:cs typeface="Courier New" pitchFamily="34" charset="-120"/>
+              </a:rPr>
+              <a:t>                     color = ~colores(Pct_Frente_Amplio), radius = TAMANO_PUNTOS,</a:t>
+            </a:r>
+            <a:endParaRPr lang="en-US" sz="1100" dirty="0"/>
+          </a:p>
+          <a:p>
+            <a:pPr marL="0" indent="0">
+              <a:spcAft>
+                <a:spcPts val="200"/>
+              </a:spcAft>
+              <a:buNone/>
+            </a:pPr>
+            <a:r>
+              <a:rPr lang="en-US" sz="1100" dirty="0">
+                <a:solidFill>
+                  <a:srgbClr val="F1E9F8"/>
+                </a:solidFill>
+                <a:latin typeface="Courier New" pitchFamily="34" charset="0"/>
+                <a:ea typeface="Courier New" pitchFamily="34" charset="-122"/>
+                <a:cs typeface="Courier New" pitchFamily="34" charset="-120"/>
+              </a:rPr>
+              <a:t>                     stroke = FALSE, fillOpacity = 0.8) |&gt;</a:t>
+            </a:r>
+            <a:endParaRPr lang="en-US" sz="1100" dirty="0"/>
+          </a:p>
+          <a:p>
+            <a:pPr marL="0" indent="0">
+              <a:spcAft>
+                <a:spcPts val="200"/>
+              </a:spcAft>
+              <a:buNone/>
+            </a:pPr>
+            <a:r>
+              <a:rPr lang="en-US" sz="1100" dirty="0">
+                <a:solidFill>
+                  <a:srgbClr val="F1E9F8"/>
+                </a:solidFill>
+                <a:latin typeface="Courier New" pitchFamily="34" charset="0"/>
+                <a:ea typeface="Courier New" pitchFamily="34" charset="-122"/>
+                <a:cs typeface="Courier New" pitchFamily="34" charset="-120"/>
+              </a:rPr>
+              <a:t>    addLegend(pal = colores, values = ~Pct_Frente_Amplio, title = "% FA")</a:t>
+            </a:r>
+            <a:endParaRPr lang="en-US" sz="1100" dirty="0"/>
+          </a:p>
+          <a:p>
+            <a:pPr marL="0" indent="0">
+              <a:spcAft>
+                <a:spcPts val="200"/>
+              </a:spcAft>
+              <a:buNone/>
+            </a:pPr>
+            <a:r>
+              <a:rPr lang="en-US" sz="1100" dirty="0">
+                <a:solidFill>
+                  <a:srgbClr val="F1E9F8"/>
+                </a:solidFill>
+                <a:latin typeface="Courier New" pitchFamily="34" charset="0"/>
+                <a:ea typeface="Courier New" pitchFamily="34" charset="-122"/>
+                <a:cs typeface="Courier New" pitchFamily="34" charset="-120"/>
+              </a:rPr>
+              <a:t>})</a:t>
+            </a:r>
+            <a:endParaRPr lang="en-US" sz="1100" dirty="0"/>
+          </a:p>
+        </p:txBody>
+      </p:sp>
+    </p:spTree>
+  </p:cSld>
+  <p:clrMapOvr>
+    <a:masterClrMapping/>
+  </p:clrMapOvr>
+</p:sld>
+</file>
+
+<file path=ppt/slides/slide16.xml><?xml version="1.0" encoding="utf-8"?>
+<p:sld xmlns:a="http://schemas.openxmlformats.org/drawingml/2006/main" xmlns:p="http://schemas.openxmlformats.org/presentationml/2006/main" xmlns:r="http://schemas.openxmlformats.org/officeDocument/2006/relationships">
+  <p:cSld>
+    <p:bg>
+      <p:bgPr>
+        <a:solidFill>
+          <a:srgbClr val="2E0A4E"/>
+        </a:solidFill>
+        <a:effectLst/>
+      </p:bgPr>
+    </p:bg>
+    <p:spTree>
+      <p:nvGrpSpPr>
+        <p:cNvPr id="1" name=""/>
+        <p:cNvGrpSpPr/>
+        <p:nvPr/>
+      </p:nvGrpSpPr>
+      <p:grpSpPr/>
+      <p:sp>
+        <p:nvSpPr>
+          <p:cNvPr id="3" name="Text 1"/>
+          <p:cNvSpPr txBox="1"/>
+          <p:nvPr/>
+        </p:nvSpPr>
+        <p:spPr>
+          <a:xfrm>
+            <a:off x="861646" y="327074"/>
+            <a:ext cx="7315200" cy="1463040"/>
+          </a:xfrm>
+          <a:prstGeom prst="rect">
+            <a:avLst/>
+          </a:prstGeom>
+          <a:noFill/>
+          <a:ln/>
+        </p:spPr>
+        <p:txBody>
+          <a:bodyPr wrap="square" lIns="0" tIns="0" rIns="0" bIns="0" rtlCol="0" anchor="t"/>
+          <a:lstStyle/>
+          <a:p>
+            <a:pPr marL="0" indent="0">
+              <a:buNone/>
+            </a:pPr>
+            <a:r>
+              <a:rPr lang="en-US" sz="3000" b="1" dirty="0" err="1">
+                <a:solidFill>
+                  <a:srgbClr val="FFFFFF"/>
+                </a:solidFill>
+                <a:latin typeface="Oswald" pitchFamily="34" charset="0"/>
+                <a:ea typeface="Oswald" pitchFamily="34" charset="-122"/>
+                <a:cs typeface="Oswald" pitchFamily="34" charset="-120"/>
+              </a:rPr>
+              <a:t>Próxima clase, sus propios datos.</a:t>
+            </a:r>
+            <a:endParaRPr lang="en-US" sz="3000" dirty="0"/>
+          </a:p>
+        </p:txBody>
+      </p:sp>
+      <p:sp>
+        <p:nvSpPr>
+          <p:cNvPr id="6" name="Text 0">
+            <a:extLst>
+              <a:ext uri="{FF2B5EF4-FFF2-40B4-BE49-F238E27FC236}">
+                <a16:creationId xmlns:a16="http://schemas.microsoft.com/office/drawing/2014/main" id="{5DEF2027-0747-FA2E-1227-2DA6BFBD4726}"/>
+              </a:ext>
+            </a:extLst>
+          </p:cNvPr>
+          <p:cNvSpPr txBox="1"/>
+          <p:nvPr/>
+        </p:nvSpPr>
+        <p:spPr>
+          <a:xfrm>
+            <a:off x="777240" y="1470074"/>
+            <a:ext cx="7040880" cy="640080"/>
+          </a:xfrm>
+          <a:prstGeom prst="rect">
+            <a:avLst/>
+          </a:prstGeom>
+          <a:noFill/>
+          <a:ln/>
+        </p:spPr>
+        <p:txBody>
+          <a:bodyPr wrap="square" lIns="0" tIns="0" rIns="0" bIns="0" rtlCol="0" anchor="ctr"/>
+          <a:lstStyle/>
+          <a:p>
+            <a:pPr marL="0" indent="0">
+              <a:buNone/>
+            </a:pPr>
+            <a:r>
+              <a:rPr lang="en-US" sz="3000" b="1" dirty="0">
+                <a:solidFill>
+                  <a:schemeClr val="bg1"/>
+                </a:solidFill>
+                <a:latin typeface="Oswald" pitchFamily="34" charset="0"/>
+                <a:ea typeface="Oswald" pitchFamily="34" charset="-122"/>
+                <a:cs typeface="Oswald" pitchFamily="34" charset="-120"/>
+              </a:rPr>
+              <a:t>Ejercicio propuesto</a:t>
+            </a:r>
+            <a:endParaRPr lang="en-US" sz="3000" dirty="0">
+              <a:solidFill>
+                <a:schemeClr val="bg1"/>
+              </a:solidFill>
+            </a:endParaRPr>
+          </a:p>
+        </p:txBody>
+      </p:sp>
+      <p:sp>
+        <p:nvSpPr>
+          <p:cNvPr id="8" name="Shape 3">
+            <a:extLst>
+              <a:ext uri="{FF2B5EF4-FFF2-40B4-BE49-F238E27FC236}">
+                <a16:creationId xmlns:a16="http://schemas.microsoft.com/office/drawing/2014/main" id="{B76805F3-EB20-5347-6375-5560CC710DE1}"/>
+              </a:ext>
+            </a:extLst>
+          </p:cNvPr>
+          <p:cNvSpPr/>
+          <p:nvPr/>
+        </p:nvSpPr>
+        <p:spPr>
+          <a:xfrm>
+            <a:off x="946053" y="2198334"/>
+            <a:ext cx="6756009" cy="1670025"/>
+          </a:xfrm>
+          <a:prstGeom prst="roundRect">
+            <a:avLst>
+              <a:gd name="adj" fmla="val 2727"/>
+            </a:avLst>
+          </a:prstGeom>
+          <a:solidFill>
+            <a:srgbClr val="F4ECFB"/>
+          </a:solidFill>
+          <a:ln w="12700">
+            <a:solidFill>
+              <a:srgbClr val="F4ECFB"/>
+            </a:solidFill>
+            <a:prstDash val="solid"/>
+          </a:ln>
+        </p:spPr>
+        <p:txBody>
+          <a:bodyPr/>
+          <a:lstStyle/>
+          <a:p>
+            <a:endParaRPr lang="en-US"/>
+          </a:p>
+        </p:txBody>
+      </p:sp>
+      <p:sp>
+        <p:nvSpPr>
+          <p:cNvPr id="10" name="Text 4">
+            <a:extLst>
+              <a:ext uri="{FF2B5EF4-FFF2-40B4-BE49-F238E27FC236}">
+                <a16:creationId xmlns:a16="http://schemas.microsoft.com/office/drawing/2014/main" id="{B7E35F91-C4B0-63AC-AA54-9A7227871712}"/>
+              </a:ext>
+            </a:extLst>
+          </p:cNvPr>
+          <p:cNvSpPr txBox="1"/>
+          <p:nvPr/>
+        </p:nvSpPr>
+        <p:spPr>
+          <a:xfrm>
+            <a:off x="1311813" y="2381214"/>
+            <a:ext cx="6148727" cy="1366384"/>
+          </a:xfrm>
+          <a:prstGeom prst="rect">
+            <a:avLst/>
+          </a:prstGeom>
+          <a:noFill/>
+          <a:ln/>
+        </p:spPr>
+        <p:txBody>
+          <a:bodyPr wrap="square" lIns="0" tIns="0" rIns="0" bIns="0" rtlCol="0" anchor="ctr"/>
+          <a:lstStyle/>
+          <a:p>
+            <a:pPr marL="0" indent="0">
+              <a:buNone/>
+            </a:pPr>
+            <a:r>
+              <a:rPr lang="en-US" sz="1700" dirty="0">
+                <a:solidFill>
+                  <a:srgbClr val="2E0A4E"/>
+                </a:solidFill>
+                <a:latin typeface="Calibri" pitchFamily="34" charset="0"/>
+                <a:ea typeface="Calibri" pitchFamily="34" charset="-122"/>
+                <a:cs typeface="Calibri" pitchFamily="34" charset="-120"/>
+              </a:rPr>
+              <a:t>Agregá un value_box() con la participación promedio, usando mean(datos()$participacion_pct). Después publicá tu versión en shinyapps.io, con otro color principal y otro fondo de mapa, y compartí la dirección.</a:t>
+            </a:r>
+            <a:endParaRPr lang="en-US" sz="1700" dirty="0"/>
           </a:p>
         </p:txBody>
       </p:sp>
@@ -2163,7 +5226,7 @@
     </p:bg>
     <p:spTree>
       <p:nvGrpSpPr>
-        <p:cNvPr id="1" name=""/>
+        <p:cNvPr id="2" name=""/>
         <p:cNvGrpSpPr/>
         <p:nvPr/>
       </p:nvGrpSpPr>
@@ -2177,7 +5240,7 @@
       </p:grpSpPr>
       <p:sp>
         <p:nvSpPr>
-          <p:cNvPr id="2" name="Text 0"/>
+          <p:cNvPr id="3" name="Text 0"/>
           <p:cNvSpPr txBox="1"/>
           <p:nvPr/>
         </p:nvSpPr>
@@ -2216,13 +5279,13 @@
       </p:sp>
       <p:sp>
         <p:nvSpPr>
-          <p:cNvPr id="5" name="Shape 3"/>
+          <p:cNvPr id="4" name="Shape 3"/>
           <p:cNvSpPr/>
           <p:nvPr/>
         </p:nvSpPr>
         <p:spPr>
           <a:xfrm>
-            <a:off x="502920" y="1280160"/>
+            <a:off x="502920" y="1188720"/>
             <a:ext cx="457200" cy="457200"/>
           </a:xfrm>
           <a:prstGeom prst="ellipse">
@@ -2248,13 +5311,13 @@
       </p:sp>
       <p:sp>
         <p:nvSpPr>
-          <p:cNvPr id="6" name="Text 4"/>
+          <p:cNvPr id="5" name="Text 4"/>
           <p:cNvSpPr txBox="1"/>
           <p:nvPr/>
         </p:nvSpPr>
         <p:spPr>
           <a:xfrm>
-            <a:off x="502920" y="1280160"/>
+            <a:off x="502920" y="1188720"/>
             <a:ext cx="457200" cy="457200"/>
           </a:xfrm>
           <a:prstGeom prst="rect">
@@ -2287,13 +5350,13 @@
       </p:sp>
       <p:sp>
         <p:nvSpPr>
-          <p:cNvPr id="7" name="Text 5"/>
+          <p:cNvPr id="6" name="Text 5"/>
           <p:cNvSpPr txBox="1"/>
           <p:nvPr/>
         </p:nvSpPr>
         <p:spPr>
           <a:xfrm>
-            <a:off x="1188720" y="1234440"/>
+            <a:off x="1188720" y="1143000"/>
             <a:ext cx="5120640" cy="548640"/>
           </a:xfrm>
           <a:prstGeom prst="rect">
@@ -2326,13 +5389,13 @@
       </p:sp>
       <p:sp>
         <p:nvSpPr>
-          <p:cNvPr id="8" name="Shape 6"/>
+          <p:cNvPr id="7" name="Shape 6"/>
           <p:cNvSpPr/>
           <p:nvPr/>
         </p:nvSpPr>
         <p:spPr>
           <a:xfrm>
-            <a:off x="502920" y="2057400"/>
+            <a:off x="502920" y="1752600"/>
             <a:ext cx="457200" cy="457200"/>
           </a:xfrm>
           <a:prstGeom prst="ellipse">
@@ -2358,13 +5421,13 @@
       </p:sp>
       <p:sp>
         <p:nvSpPr>
-          <p:cNvPr id="9" name="Text 7"/>
+          <p:cNvPr id="8" name="Text 7"/>
           <p:cNvSpPr txBox="1"/>
           <p:nvPr/>
         </p:nvSpPr>
         <p:spPr>
           <a:xfrm>
-            <a:off x="502920" y="2057400"/>
+            <a:off x="502920" y="1752600"/>
             <a:ext cx="457200" cy="457200"/>
           </a:xfrm>
           <a:prstGeom prst="rect">
@@ -2397,13 +5460,13 @@
       </p:sp>
       <p:sp>
         <p:nvSpPr>
-          <p:cNvPr id="10" name="Text 8"/>
+          <p:cNvPr id="9" name="Text 8"/>
           <p:cNvSpPr txBox="1"/>
           <p:nvPr/>
         </p:nvSpPr>
         <p:spPr>
           <a:xfrm>
-            <a:off x="1188720" y="2011680"/>
+            <a:off x="1188720" y="1706880"/>
             <a:ext cx="5120640" cy="548640"/>
           </a:xfrm>
           <a:prstGeom prst="rect">
@@ -2428,7 +5491,7 @@
                 <a:ea typeface="Calibri" pitchFamily="34" charset="-122"/>
                 <a:cs typeface="Calibri" pitchFamily="34" charset="-120"/>
               </a:rPr>
-              <a:t>Organizar la app con una barra de navegación, page_navbar().</a:t>
+              <a:t>Organizar la app con page_navbar() y jerarquizar con value_box() y card().</a:t>
             </a:r>
             <a:endParaRPr lang="en-US" sz="1500" dirty="0"/>
           </a:p>
@@ -2436,13 +5499,13 @@
       </p:sp>
       <p:sp>
         <p:nvSpPr>
-          <p:cNvPr id="11" name="Shape 9"/>
+          <p:cNvPr id="10" name="Shape 9"/>
           <p:cNvSpPr/>
           <p:nvPr/>
         </p:nvSpPr>
         <p:spPr>
           <a:xfrm>
-            <a:off x="502920" y="2834640"/>
+            <a:off x="502920" y="2316480"/>
             <a:ext cx="457200" cy="457200"/>
           </a:xfrm>
           <a:prstGeom prst="ellipse">
@@ -2468,13 +5531,13 @@
       </p:sp>
       <p:sp>
         <p:nvSpPr>
-          <p:cNvPr id="12" name="Text 10"/>
+          <p:cNvPr id="11" name="Text 10"/>
           <p:cNvSpPr txBox="1"/>
           <p:nvPr/>
         </p:nvSpPr>
         <p:spPr>
           <a:xfrm>
-            <a:off x="502920" y="2834640"/>
+            <a:off x="502920" y="2316480"/>
             <a:ext cx="457200" cy="457200"/>
           </a:xfrm>
           <a:prstGeom prst="rect">
@@ -2507,13 +5570,13 @@
       </p:sp>
       <p:sp>
         <p:nvSpPr>
-          <p:cNvPr id="13" name="Text 11"/>
+          <p:cNvPr id="12" name="Text 11"/>
           <p:cNvSpPr txBox="1"/>
           <p:nvPr/>
         </p:nvSpPr>
         <p:spPr>
           <a:xfrm>
-            <a:off x="1188720" y="2788920"/>
+            <a:off x="1188720" y="2270760"/>
             <a:ext cx="5120640" cy="548640"/>
           </a:xfrm>
           <a:prstGeom prst="rect">
@@ -2538,7 +5601,7 @@
                 <a:ea typeface="Calibri" pitchFamily="34" charset="-122"/>
                 <a:cs typeface="Calibri" pitchFamily="34" charset="-120"/>
               </a:rPr>
-              <a:t>Jerarquizar la información con value_box() y card().</a:t>
+              <a:t>Mostrar tablas interactivas con DT.</a:t>
             </a:r>
             <a:endParaRPr lang="en-US" sz="1500" dirty="0"/>
           </a:p>
@@ -2546,13 +5609,13 @@
       </p:sp>
       <p:sp>
         <p:nvSpPr>
-          <p:cNvPr id="14" name="Shape 12"/>
+          <p:cNvPr id="13" name="Shape 12"/>
           <p:cNvSpPr/>
           <p:nvPr/>
         </p:nvSpPr>
         <p:spPr>
           <a:xfrm>
-            <a:off x="502920" y="3611880"/>
+            <a:off x="502920" y="2880360"/>
             <a:ext cx="457200" cy="457200"/>
           </a:xfrm>
           <a:prstGeom prst="ellipse">
@@ -2578,13 +5641,13 @@
       </p:sp>
       <p:sp>
         <p:nvSpPr>
-          <p:cNvPr id="15" name="Text 13"/>
+          <p:cNvPr id="14" name="Text 13"/>
           <p:cNvSpPr txBox="1"/>
           <p:nvPr/>
         </p:nvSpPr>
         <p:spPr>
           <a:xfrm>
-            <a:off x="502920" y="3611880"/>
+            <a:off x="502920" y="2880360"/>
             <a:ext cx="457200" cy="457200"/>
           </a:xfrm>
           <a:prstGeom prst="rect">
@@ -2617,13 +5680,13 @@
       </p:sp>
       <p:sp>
         <p:nvSpPr>
-          <p:cNvPr id="16" name="Text 14"/>
+          <p:cNvPr id="15" name="Text 14"/>
           <p:cNvSpPr txBox="1"/>
           <p:nvPr/>
         </p:nvSpPr>
         <p:spPr>
           <a:xfrm>
-            <a:off x="1188720" y="3566160"/>
+            <a:off x="1188720" y="2834640"/>
             <a:ext cx="5120640" cy="548640"/>
           </a:xfrm>
           <a:prstGeom prst="rect">
@@ -2648,7 +5711,7 @@
                 <a:ea typeface="Calibri" pitchFamily="34" charset="-122"/>
                 <a:cs typeface="Calibri" pitchFamily="34" charset="-120"/>
               </a:rPr>
-              <a:t>Mostrar tablas interactivas con DT.</a:t>
+              <a:t>Integrar lo aprendido en tres paneles y hacer mapas interactivos con leaflet.</a:t>
             </a:r>
             <a:endParaRPr lang="en-US" sz="1500" dirty="0"/>
           </a:p>
@@ -2656,7 +5719,7 @@
       </p:sp>
       <p:sp>
         <p:nvSpPr>
-          <p:cNvPr id="17" name="Text 15"/>
+          <p:cNvPr id="16" name="Text 15"/>
           <p:cNvSpPr txBox="1"/>
           <p:nvPr/>
         </p:nvSpPr>
@@ -2690,6 +5753,226 @@
               <a:t>C7</a:t>
             </a:r>
             <a:endParaRPr lang="en-US" sz="11000" dirty="0"/>
+          </a:p>
+        </p:txBody>
+      </p:sp>
+      <p:sp>
+        <p:nvSpPr>
+          <p:cNvPr id="17" name="Shape 12"/>
+          <p:cNvSpPr/>
+          <p:nvPr/>
+        </p:nvSpPr>
+        <p:spPr>
+          <a:xfrm>
+            <a:off x="502920" y="3444240"/>
+            <a:ext cx="457200" cy="457200"/>
+          </a:xfrm>
+          <a:prstGeom prst="ellipse">
+            <a:avLst/>
+          </a:prstGeom>
+          <a:solidFill>
+            <a:srgbClr val="5A189A"/>
+          </a:solidFill>
+          <a:ln w="12700">
+            <a:solidFill>
+              <a:srgbClr val="5A189A"/>
+            </a:solidFill>
+            <a:prstDash val="solid"/>
+          </a:ln>
+        </p:spPr>
+        <p:txBody>
+          <a:bodyPr/>
+          <a:lstStyle/>
+          <a:p>
+            <a:endParaRPr lang="en-US"/>
+          </a:p>
+        </p:txBody>
+      </p:sp>
+      <p:sp>
+        <p:nvSpPr>
+          <p:cNvPr id="18" name="Text 13"/>
+          <p:cNvSpPr txBox="1"/>
+          <p:nvPr/>
+        </p:nvSpPr>
+        <p:spPr>
+          <a:xfrm>
+            <a:off x="502920" y="3444240"/>
+            <a:ext cx="457200" cy="457200"/>
+          </a:xfrm>
+          <a:prstGeom prst="rect">
+            <a:avLst/>
+          </a:prstGeom>
+          <a:noFill/>
+          <a:ln/>
+        </p:spPr>
+        <p:txBody>
+          <a:bodyPr wrap="square" lIns="0" tIns="0" rIns="0" bIns="0" rtlCol="0" anchor="ctr"/>
+          <a:lstStyle/>
+          <a:p>
+            <a:pPr marL="0" indent="0" algn="ctr">
+              <a:buNone/>
+            </a:pPr>
+            <a:r>
+              <a:rPr lang="en-US" sz="1600" b="1" dirty="0">
+                <a:solidFill>
+                  <a:srgbClr val="FFFFFF"/>
+                </a:solidFill>
+                <a:latin typeface="Oswald" pitchFamily="34" charset="0"/>
+                <a:ea typeface="Oswald" pitchFamily="34" charset="-122"/>
+                <a:cs typeface="Oswald" pitchFamily="34" charset="-120"/>
+              </a:rPr>
+              <a:t>5</a:t>
+            </a:r>
+            <a:endParaRPr lang="en-US" sz="1600" dirty="0"/>
+          </a:p>
+        </p:txBody>
+      </p:sp>
+      <p:sp>
+        <p:nvSpPr>
+          <p:cNvPr id="19" name="Text 14"/>
+          <p:cNvSpPr txBox="1"/>
+          <p:nvPr/>
+        </p:nvSpPr>
+        <p:spPr>
+          <a:xfrm>
+            <a:off x="1188720" y="3398520"/>
+            <a:ext cx="5120640" cy="548640"/>
+          </a:xfrm>
+          <a:prstGeom prst="rect">
+            <a:avLst/>
+          </a:prstGeom>
+          <a:noFill/>
+          <a:ln/>
+        </p:spPr>
+        <p:txBody>
+          <a:bodyPr wrap="square" lIns="0" tIns="0" rIns="0" bIns="0" rtlCol="0" anchor="ctr"/>
+          <a:lstStyle/>
+          <a:p>
+            <a:pPr marL="0" indent="0">
+              <a:buNone/>
+            </a:pPr>
+            <a:r>
+              <a:rPr lang="en-US" sz="1500" dirty="0" err="1">
+                <a:solidFill>
+                  <a:srgbClr val="2E0A4E"/>
+                </a:solidFill>
+                <a:latin typeface="Calibri" pitchFamily="34" charset="0"/>
+                <a:ea typeface="Calibri" pitchFamily="34" charset="-122"/>
+                <a:cs typeface="Calibri" pitchFamily="34" charset="-120"/>
+              </a:rPr>
+              <a:t>Filtrar varios conjuntos de datos con los mismos controles.</a:t>
+            </a:r>
+            <a:endParaRPr lang="en-US" sz="1500" dirty="0"/>
+          </a:p>
+        </p:txBody>
+      </p:sp>
+      <p:sp>
+        <p:nvSpPr>
+          <p:cNvPr id="20" name="Shape 12"/>
+          <p:cNvSpPr/>
+          <p:nvPr/>
+        </p:nvSpPr>
+        <p:spPr>
+          <a:xfrm>
+            <a:off x="502920" y="4008120"/>
+            <a:ext cx="457200" cy="457200"/>
+          </a:xfrm>
+          <a:prstGeom prst="ellipse">
+            <a:avLst/>
+          </a:prstGeom>
+          <a:solidFill>
+            <a:srgbClr val="5A189A"/>
+          </a:solidFill>
+          <a:ln w="12700">
+            <a:solidFill>
+              <a:srgbClr val="5A189A"/>
+            </a:solidFill>
+            <a:prstDash val="solid"/>
+          </a:ln>
+        </p:spPr>
+        <p:txBody>
+          <a:bodyPr/>
+          <a:lstStyle/>
+          <a:p>
+            <a:endParaRPr lang="en-US"/>
+          </a:p>
+        </p:txBody>
+      </p:sp>
+      <p:sp>
+        <p:nvSpPr>
+          <p:cNvPr id="21" name="Text 13"/>
+          <p:cNvSpPr txBox="1"/>
+          <p:nvPr/>
+        </p:nvSpPr>
+        <p:spPr>
+          <a:xfrm>
+            <a:off x="502920" y="4008120"/>
+            <a:ext cx="457200" cy="457200"/>
+          </a:xfrm>
+          <a:prstGeom prst="rect">
+            <a:avLst/>
+          </a:prstGeom>
+          <a:noFill/>
+          <a:ln/>
+        </p:spPr>
+        <p:txBody>
+          <a:bodyPr wrap="square" lIns="0" tIns="0" rIns="0" bIns="0" rtlCol="0" anchor="ctr"/>
+          <a:lstStyle/>
+          <a:p>
+            <a:pPr marL="0" indent="0" algn="ctr">
+              <a:buNone/>
+            </a:pPr>
+            <a:r>
+              <a:rPr lang="en-US" sz="1600" b="1" dirty="0">
+                <a:solidFill>
+                  <a:srgbClr val="FFFFFF"/>
+                </a:solidFill>
+                <a:latin typeface="Oswald" pitchFamily="34" charset="0"/>
+                <a:ea typeface="Oswald" pitchFamily="34" charset="-122"/>
+                <a:cs typeface="Oswald" pitchFamily="34" charset="-120"/>
+              </a:rPr>
+              <a:t>6</a:t>
+            </a:r>
+            <a:endParaRPr lang="en-US" sz="1600" dirty="0"/>
+          </a:p>
+        </p:txBody>
+      </p:sp>
+      <p:sp>
+        <p:nvSpPr>
+          <p:cNvPr id="22" name="Text 14"/>
+          <p:cNvSpPr txBox="1"/>
+          <p:nvPr/>
+        </p:nvSpPr>
+        <p:spPr>
+          <a:xfrm>
+            <a:off x="1188720" y="3962400"/>
+            <a:ext cx="5120640" cy="548640"/>
+          </a:xfrm>
+          <a:prstGeom prst="rect">
+            <a:avLst/>
+          </a:prstGeom>
+          <a:noFill/>
+          <a:ln/>
+        </p:spPr>
+        <p:txBody>
+          <a:bodyPr wrap="square" lIns="0" tIns="0" rIns="0" bIns="0" rtlCol="0" anchor="ctr"/>
+          <a:lstStyle/>
+          <a:p>
+            <a:pPr marL="0" indent="0">
+              <a:buNone/>
+            </a:pPr>
+            <a:r>
+              <a:rPr lang="en-US" sz="1500" dirty="0" err="1">
+                <a:solidFill>
+                  <a:srgbClr val="2E0A4E"/>
+                </a:solidFill>
+                <a:latin typeface="Calibri" pitchFamily="34" charset="0"/>
+                <a:ea typeface="Calibri" pitchFamily="34" charset="-122"/>
+                <a:cs typeface="Calibri" pitchFamily="34" charset="-120"/>
+              </a:rPr>
+              <a:t>Publicar la app en shinyapps.io.</a:t>
+            </a:r>
+            <a:endParaRPr lang="en-US" sz="1500" dirty="0"/>
           </a:p>
         </p:txBody>
       </p:sp>
@@ -3045,15 +6328,15 @@
           <p:nvPr/>
         </p:nvPicPr>
         <p:blipFill>
-          <a:blip r:embed="rId7"/>
+          <a:blip r:embed="rId8"/>
           <a:stretch>
             <a:fillRect/>
           </a:stretch>
         </p:blipFill>
         <p:spPr>
           <a:xfrm>
-            <a:off x="4434840" y="1227753"/>
-            <a:ext cx="4480560" cy="2985173"/>
+            <a:off x="4434840" y="1506480"/>
+            <a:ext cx="4480560" cy="2987040"/>
           </a:xfrm>
           <a:prstGeom prst="rect">
             <a:avLst/>
@@ -3435,15 +6718,15 @@
           <p:nvPr/>
         </p:nvPicPr>
         <p:blipFill>
-          <a:blip r:embed="rId7"/>
+          <a:blip r:embed="rId8"/>
           <a:stretch>
             <a:fillRect/>
           </a:stretch>
         </p:blipFill>
         <p:spPr>
           <a:xfrm>
-            <a:off x="4434840" y="1227753"/>
-            <a:ext cx="4480560" cy="2985173"/>
+            <a:off x="4434840" y="1506480"/>
+            <a:ext cx="4480560" cy="2987040"/>
           </a:xfrm>
           <a:prstGeom prst="rect">
             <a:avLst/>
@@ -3617,7 +6900,7 @@
                 <a:ea typeface="Oswald" pitchFamily="34" charset="-122"/>
                 <a:cs typeface="Oswald" pitchFamily="34" charset="-120"/>
               </a:rPr>
-              <a:t>OBJETIVO 3</a:t>
+              <a:t>OBJETIVO 2</a:t>
             </a:r>
             <a:endParaRPr lang="en-US" sz="1600" dirty="0"/>
           </a:p>
@@ -3842,14 +7125,14 @@
           <p:nvPr/>
         </p:nvPicPr>
         <p:blipFill>
-          <a:blip r:embed="rId7"/>
+          <a:blip r:embed="rId8"/>
           <a:stretch>
             <a:fillRect/>
           </a:stretch>
         </p:blipFill>
         <p:spPr>
           <a:xfrm>
-            <a:off x="4434840" y="1835643"/>
+            <a:off x="4434840" y="2115304"/>
             <a:ext cx="4480560" cy="1769393"/>
           </a:xfrm>
           <a:prstGeom prst="rect">
@@ -4029,7 +7312,7 @@
                 <a:ea typeface="Oswald" pitchFamily="34" charset="-122"/>
                 <a:cs typeface="Oswald" pitchFamily="34" charset="-120"/>
               </a:rPr>
-              <a:t>OBJETIVO 4</a:t>
+              <a:t>OBJETIVO 3</a:t>
             </a:r>
             <a:endParaRPr lang="en-US" sz="1600" dirty="0"/>
           </a:p>
@@ -4232,15 +7515,15 @@
           <p:nvPr/>
         </p:nvPicPr>
         <p:blipFill>
-          <a:blip r:embed="rId7"/>
+          <a:blip r:embed="rId8"/>
           <a:stretch>
             <a:fillRect/>
           </a:stretch>
         </p:blipFill>
         <p:spPr>
           <a:xfrm>
-            <a:off x="4434840" y="1578796"/>
-            <a:ext cx="4480560" cy="2283087"/>
+            <a:off x="4434840" y="1722274"/>
+            <a:ext cx="4480560" cy="2555452"/>
           </a:xfrm>
           <a:prstGeom prst="rect">
             <a:avLst/>
@@ -4369,7 +7652,7 @@
                 <a:ea typeface="Oswald" pitchFamily="34" charset="-122"/>
                 <a:cs typeface="Oswald" pitchFamily="34" charset="-120"/>
               </a:rPr>
-              <a:t> </a:t>
+              <a:t> (1)</a:t>
             </a:r>
             <a:endParaRPr lang="en-US" sz="3000" dirty="0"/>
           </a:p>
@@ -5246,7 +8529,7 @@
                 <a:ea typeface="Oswald" pitchFamily="34" charset="-122"/>
                 <a:cs typeface="Oswald" pitchFamily="34" charset="-120"/>
               </a:rPr>
-              <a:t>Código clave</a:t>
+              <a:t>Código clave (1)</a:t>
             </a:r>
             <a:endParaRPr lang="en-US" sz="3000" dirty="0"/>
           </a:p>
@@ -5640,7 +8923,7 @@
                 <a:ea typeface="Courier New" pitchFamily="34" charset="-122"/>
                 <a:cs typeface="Courier New" pitchFamily="34" charset="-120"/>
               </a:rPr>
-              <a:t>  nav_panel("Tabla", card(DTOutput("tabla")))</a:t>
+              <a:t>  nav_panel("Tablas", card(DTOutput("tabla")))</a:t>
             </a:r>
             <a:endParaRPr lang="en-US" sz="1100" dirty="0"/>
           </a:p>
@@ -5703,212 +8986,6 @@
               <a:t>output$tabla &lt;- renderDT({ datatable(datos(), rownames = FALSE) })</a:t>
             </a:r>
             <a:endParaRPr lang="en-US" sz="1100" dirty="0"/>
-          </a:p>
-        </p:txBody>
-      </p:sp>
-    </p:spTree>
-  </p:cSld>
-  <p:clrMapOvr>
-    <a:masterClrMapping/>
-  </p:clrMapOvr>
-</p:sld>
-</file>
-
-<file path=ppt/slides/slide9.xml><?xml version="1.0" encoding="utf-8"?>
-<p:sld xmlns:a="http://schemas.openxmlformats.org/drawingml/2006/main" xmlns:r="http://schemas.openxmlformats.org/officeDocument/2006/relationships" xmlns:p="http://schemas.openxmlformats.org/presentationml/2006/main">
-  <p:cSld name="Slide 7">
-    <p:bg>
-      <p:bgPr>
-        <a:solidFill>
-          <a:srgbClr val="2E0A4E"/>
-        </a:solidFill>
-        <a:effectLst/>
-      </p:bgPr>
-    </p:bg>
-    <p:spTree>
-      <p:nvGrpSpPr>
-        <p:cNvPr id="1" name=""/>
-        <p:cNvGrpSpPr/>
-        <p:nvPr/>
-      </p:nvGrpSpPr>
-      <p:grpSpPr>
-        <a:xfrm>
-          <a:off x="0" y="0"/>
-          <a:ext cx="0" cy="0"/>
-          <a:chOff x="0" y="0"/>
-          <a:chExt cx="0" cy="0"/>
-        </a:xfrm>
-      </p:grpSpPr>
-      <p:sp>
-        <p:nvSpPr>
-          <p:cNvPr id="3" name="Text 1"/>
-          <p:cNvSpPr txBox="1"/>
-          <p:nvPr/>
-        </p:nvSpPr>
-        <p:spPr>
-          <a:xfrm>
-            <a:off x="861646" y="327074"/>
-            <a:ext cx="7315200" cy="1463040"/>
-          </a:xfrm>
-          <a:prstGeom prst="rect">
-            <a:avLst/>
-          </a:prstGeom>
-          <a:noFill/>
-          <a:ln/>
-        </p:spPr>
-        <p:txBody>
-          <a:bodyPr wrap="square" lIns="0" tIns="0" rIns="0" bIns="0" rtlCol="0" anchor="t"/>
-          <a:lstStyle/>
-          <a:p>
-            <a:pPr marL="0" indent="0">
-              <a:buNone/>
-            </a:pPr>
-            <a:r>
-              <a:rPr lang="en-US" sz="3000" b="1" dirty="0" err="1">
-                <a:solidFill>
-                  <a:srgbClr val="FFFFFF"/>
-                </a:solidFill>
-                <a:latin typeface="Oswald" pitchFamily="34" charset="0"/>
-                <a:ea typeface="Oswald" pitchFamily="34" charset="-122"/>
-                <a:cs typeface="Oswald" pitchFamily="34" charset="-120"/>
-              </a:rPr>
-              <a:t>Próxima clase, publicar la app.</a:t>
-            </a:r>
-            <a:endParaRPr lang="en-US" sz="3000" dirty="0"/>
-          </a:p>
-        </p:txBody>
-      </p:sp>
-      <p:sp>
-        <p:nvSpPr>
-          <p:cNvPr id="6" name="Text 0">
-            <a:extLst>
-              <a:ext uri="{FF2B5EF4-FFF2-40B4-BE49-F238E27FC236}">
-                <a16:creationId xmlns:a16="http://schemas.microsoft.com/office/drawing/2014/main" id="{5DEF2027-0747-FA2E-1227-2DA6BFBD4726}"/>
-              </a:ext>
-            </a:extLst>
-          </p:cNvPr>
-          <p:cNvSpPr txBox="1"/>
-          <p:nvPr/>
-        </p:nvSpPr>
-        <p:spPr>
-          <a:xfrm>
-            <a:off x="777240" y="1470074"/>
-            <a:ext cx="7040880" cy="640080"/>
-          </a:xfrm>
-          <a:prstGeom prst="rect">
-            <a:avLst/>
-          </a:prstGeom>
-          <a:noFill/>
-          <a:ln/>
-        </p:spPr>
-        <p:txBody>
-          <a:bodyPr wrap="square" lIns="0" tIns="0" rIns="0" bIns="0" rtlCol="0" anchor="ctr"/>
-          <a:lstStyle/>
-          <a:p>
-            <a:pPr marL="0" indent="0">
-              <a:buNone/>
-            </a:pPr>
-            <a:r>
-              <a:rPr lang="en-US" sz="3000" b="1" dirty="0">
-                <a:solidFill>
-                  <a:schemeClr val="bg1"/>
-                </a:solidFill>
-                <a:latin typeface="Oswald" pitchFamily="34" charset="0"/>
-                <a:ea typeface="Oswald" pitchFamily="34" charset="-122"/>
-                <a:cs typeface="Oswald" pitchFamily="34" charset="-120"/>
-              </a:rPr>
-              <a:t>Ejercicio propuesto</a:t>
-            </a:r>
-            <a:endParaRPr lang="en-US" sz="3000" dirty="0">
-              <a:solidFill>
-                <a:schemeClr val="bg1"/>
-              </a:solidFill>
-            </a:endParaRPr>
-          </a:p>
-        </p:txBody>
-      </p:sp>
-      <p:sp>
-        <p:nvSpPr>
-          <p:cNvPr id="8" name="Shape 3">
-            <a:extLst>
-              <a:ext uri="{FF2B5EF4-FFF2-40B4-BE49-F238E27FC236}">
-                <a16:creationId xmlns:a16="http://schemas.microsoft.com/office/drawing/2014/main" id="{B76805F3-EB20-5347-6375-5560CC710DE1}"/>
-              </a:ext>
-            </a:extLst>
-          </p:cNvPr>
-          <p:cNvSpPr/>
-          <p:nvPr/>
-        </p:nvSpPr>
-        <p:spPr>
-          <a:xfrm>
-            <a:off x="946053" y="2198334"/>
-            <a:ext cx="6756009" cy="1670025"/>
-          </a:xfrm>
-          <a:prstGeom prst="roundRect">
-            <a:avLst>
-              <a:gd name="adj" fmla="val 2727"/>
-            </a:avLst>
-          </a:prstGeom>
-          <a:solidFill>
-            <a:srgbClr val="F4ECFB"/>
-          </a:solidFill>
-          <a:ln w="12700">
-            <a:solidFill>
-              <a:srgbClr val="F4ECFB"/>
-            </a:solidFill>
-            <a:prstDash val="solid"/>
-          </a:ln>
-        </p:spPr>
-        <p:txBody>
-          <a:bodyPr/>
-          <a:lstStyle/>
-          <a:p>
-            <a:endParaRPr lang="en-US"/>
-          </a:p>
-        </p:txBody>
-      </p:sp>
-      <p:sp>
-        <p:nvSpPr>
-          <p:cNvPr id="10" name="Text 4">
-            <a:extLst>
-              <a:ext uri="{FF2B5EF4-FFF2-40B4-BE49-F238E27FC236}">
-                <a16:creationId xmlns:a16="http://schemas.microsoft.com/office/drawing/2014/main" id="{B7E35F91-C4B0-63AC-AA54-9A7227871712}"/>
-              </a:ext>
-            </a:extLst>
-          </p:cNvPr>
-          <p:cNvSpPr txBox="1"/>
-          <p:nvPr/>
-        </p:nvSpPr>
-        <p:spPr>
-          <a:xfrm>
-            <a:off x="1311813" y="2381214"/>
-            <a:ext cx="6148727" cy="1366384"/>
-          </a:xfrm>
-          <a:prstGeom prst="rect">
-            <a:avLst/>
-          </a:prstGeom>
-          <a:noFill/>
-          <a:ln/>
-        </p:spPr>
-        <p:txBody>
-          <a:bodyPr wrap="square" lIns="0" tIns="0" rIns="0" bIns="0" rtlCol="0" anchor="ctr"/>
-          <a:lstStyle/>
-          <a:p>
-            <a:pPr marL="0" indent="0">
-              <a:buNone/>
-            </a:pPr>
-            <a:r>
-              <a:rPr lang="en-US" sz="1700" dirty="0">
-                <a:solidFill>
-                  <a:srgbClr val="2E0A4E"/>
-                </a:solidFill>
-                <a:latin typeface="Calibri" pitchFamily="34" charset="0"/>
-                <a:ea typeface="Calibri" pitchFamily="34" charset="-122"/>
-                <a:cs typeface="Calibri" pitchFamily="34" charset="-120"/>
-              </a:rPr>
-              <a:t>Agregá un value_box() con la participación promedio, usando mean(datos()$participacion_pct).</a:t>
-            </a:r>
-            <a:endParaRPr lang="en-US" sz="1700" dirty="0"/>
           </a:p>
         </p:txBody>
       </p:sp>

</xml_diff>